<commit_message>
Added timing diagram for data bus transfers
The drawing was made in L1IsDrawings.pptx then a screen shot of it was pasted into CpuDesign.docx
</commit_message>
<xml_diff>
--- a/CPU Design/L1IsDrawings.pptx
+++ b/CPU Design/L1IsDrawings.pptx
@@ -7,6 +7,7 @@
   <p:sldIdLst>
     <p:sldId id="256" r:id="rId2"/>
     <p:sldId id="258" r:id="rId3"/>
+    <p:sldId id="259" r:id="rId4"/>
   </p:sldIdLst>
   <p:sldSz cx="9144000" cy="6858000" type="screen4x3"/>
   <p:notesSz cx="6858000" cy="9144000"/>
@@ -290,7 +291,7 @@
             <a:fld id="{1D8BD707-D9CF-40AE-B4C6-C98DA3205C09}" type="datetimeFigureOut">
               <a:rPr lang="en-US" smtClean="0"/>
               <a:pPr/>
-              <a:t>6/28/2026</a:t>
+              <a:t>6/29/2026</a:t>
             </a:fld>
             <a:endParaRPr lang="en-US"/>
           </a:p>
@@ -457,7 +458,7 @@
             <a:fld id="{1D8BD707-D9CF-40AE-B4C6-C98DA3205C09}" type="datetimeFigureOut">
               <a:rPr lang="en-US" smtClean="0"/>
               <a:pPr/>
-              <a:t>6/28/2026</a:t>
+              <a:t>6/29/2026</a:t>
             </a:fld>
             <a:endParaRPr lang="en-US"/>
           </a:p>
@@ -634,7 +635,7 @@
             <a:fld id="{1D8BD707-D9CF-40AE-B4C6-C98DA3205C09}" type="datetimeFigureOut">
               <a:rPr lang="en-US" smtClean="0"/>
               <a:pPr/>
-              <a:t>6/28/2026</a:t>
+              <a:t>6/29/2026</a:t>
             </a:fld>
             <a:endParaRPr lang="en-US"/>
           </a:p>
@@ -801,7 +802,7 @@
             <a:fld id="{1D8BD707-D9CF-40AE-B4C6-C98DA3205C09}" type="datetimeFigureOut">
               <a:rPr lang="en-US" smtClean="0"/>
               <a:pPr/>
-              <a:t>6/28/2026</a:t>
+              <a:t>6/29/2026</a:t>
             </a:fld>
             <a:endParaRPr lang="en-US"/>
           </a:p>
@@ -1044,7 +1045,7 @@
             <a:fld id="{1D8BD707-D9CF-40AE-B4C6-C98DA3205C09}" type="datetimeFigureOut">
               <a:rPr lang="en-US" smtClean="0"/>
               <a:pPr/>
-              <a:t>6/28/2026</a:t>
+              <a:t>6/29/2026</a:t>
             </a:fld>
             <a:endParaRPr lang="en-US"/>
           </a:p>
@@ -1329,7 +1330,7 @@
             <a:fld id="{1D8BD707-D9CF-40AE-B4C6-C98DA3205C09}" type="datetimeFigureOut">
               <a:rPr lang="en-US" smtClean="0"/>
               <a:pPr/>
-              <a:t>6/28/2026</a:t>
+              <a:t>6/29/2026</a:t>
             </a:fld>
             <a:endParaRPr lang="en-US"/>
           </a:p>
@@ -1748,7 +1749,7 @@
             <a:fld id="{1D8BD707-D9CF-40AE-B4C6-C98DA3205C09}" type="datetimeFigureOut">
               <a:rPr lang="en-US" smtClean="0"/>
               <a:pPr/>
-              <a:t>6/28/2026</a:t>
+              <a:t>6/29/2026</a:t>
             </a:fld>
             <a:endParaRPr lang="en-US"/>
           </a:p>
@@ -1863,7 +1864,7 @@
             <a:fld id="{1D8BD707-D9CF-40AE-B4C6-C98DA3205C09}" type="datetimeFigureOut">
               <a:rPr lang="en-US" smtClean="0"/>
               <a:pPr/>
-              <a:t>6/28/2026</a:t>
+              <a:t>6/29/2026</a:t>
             </a:fld>
             <a:endParaRPr lang="en-US"/>
           </a:p>
@@ -1955,7 +1956,7 @@
             <a:fld id="{1D8BD707-D9CF-40AE-B4C6-C98DA3205C09}" type="datetimeFigureOut">
               <a:rPr lang="en-US" smtClean="0"/>
               <a:pPr/>
-              <a:t>6/28/2026</a:t>
+              <a:t>6/29/2026</a:t>
             </a:fld>
             <a:endParaRPr lang="en-US"/>
           </a:p>
@@ -2229,7 +2230,7 @@
             <a:fld id="{1D8BD707-D9CF-40AE-B4C6-C98DA3205C09}" type="datetimeFigureOut">
               <a:rPr lang="en-US" smtClean="0"/>
               <a:pPr/>
-              <a:t>6/28/2026</a:t>
+              <a:t>6/29/2026</a:t>
             </a:fld>
             <a:endParaRPr lang="en-US"/>
           </a:p>
@@ -2479,7 +2480,7 @@
             <a:fld id="{1D8BD707-D9CF-40AE-B4C6-C98DA3205C09}" type="datetimeFigureOut">
               <a:rPr lang="en-US" smtClean="0"/>
               <a:pPr/>
-              <a:t>6/28/2026</a:t>
+              <a:t>6/29/2026</a:t>
             </a:fld>
             <a:endParaRPr lang="en-US"/>
           </a:p>
@@ -2689,7 +2690,7 @@
             <a:fld id="{1D8BD707-D9CF-40AE-B4C6-C98DA3205C09}" type="datetimeFigureOut">
               <a:rPr lang="en-US" smtClean="0"/>
               <a:pPr/>
-              <a:t>6/28/2026</a:t>
+              <a:t>6/29/2026</a:t>
             </a:fld>
             <a:endParaRPr lang="en-US"/>
           </a:p>
@@ -3100,11 +3101,7 @@
           <a:p>
             <a:r>
               <a:rPr lang="en-GB" dirty="0" smtClean="0"/>
-              <a:t>This file contains drawings which are used as </a:t>
-            </a:r>
-            <a:r>
-              <a:rPr lang="en-GB" dirty="0" smtClean="0"/>
-              <a:t>figures in L1IsDesign.docx</a:t>
+              <a:t>This file contains drawings which are used as figures in L1IsDesign.docx</a:t>
             </a:r>
             <a:endParaRPr lang="en-GB" dirty="0"/>
           </a:p>
@@ -3231,15 +3228,7 @@
                   <a:schemeClr val="tx1"/>
                 </a:solidFill>
               </a:rPr>
-              <a:t>Data for </a:t>
-            </a:r>
-            <a:r>
-              <a:rPr lang="en-GB" dirty="0" smtClean="0">
-                <a:solidFill>
-                  <a:schemeClr val="tx1"/>
-                </a:solidFill>
-              </a:rPr>
-              <a:t>Sequence Number 1</a:t>
+              <a:t>Data for Sequence Number 1</a:t>
             </a:r>
             <a:endParaRPr lang="en-GB" dirty="0">
               <a:solidFill>
@@ -3525,21 +3514,8 @@
                   <a:schemeClr val="tx1"/>
                 </a:solidFill>
               </a:rPr>
-              <a:t>Data for </a:t>
-            </a:r>
-            <a:r>
-              <a:rPr lang="en-GB" dirty="0" smtClean="0">
-                <a:solidFill>
-                  <a:schemeClr val="tx1"/>
-                </a:solidFill>
-              </a:rPr>
-              <a:t>Sequence Number 31</a:t>
-            </a:r>
-            <a:endParaRPr lang="en-GB" dirty="0" smtClean="0">
-              <a:solidFill>
-                <a:schemeClr val="tx1"/>
-              </a:solidFill>
-            </a:endParaRPr>
+              <a:t>Data for Sequence Number 31</a:t>
+            </a:r>
           </a:p>
         </p:txBody>
       </p:sp>
@@ -3600,6 +3576,2043 @@
               <a:t>0x3FF</a:t>
             </a:r>
             <a:endParaRPr lang="en-GB" dirty="0"/>
+          </a:p>
+        </p:txBody>
+      </p:sp>
+    </p:spTree>
+  </p:cSld>
+  <p:clrMapOvr>
+    <a:masterClrMapping/>
+  </p:clrMapOvr>
+</p:sld>
+</file>
+
+<file path=ppt/slides/slide3.xml><?xml version="1.0" encoding="utf-8"?>
+<p:sld xmlns:a="http://schemas.openxmlformats.org/drawingml/2006/main" xmlns:r="http://schemas.openxmlformats.org/officeDocument/2006/relationships" xmlns:p="http://schemas.openxmlformats.org/presentationml/2006/main">
+  <p:cSld>
+    <p:spTree>
+      <p:nvGrpSpPr>
+        <p:cNvPr id="1" name=""/>
+        <p:cNvGrpSpPr/>
+        <p:nvPr/>
+      </p:nvGrpSpPr>
+      <p:grpSpPr>
+        <a:xfrm>
+          <a:off x="0" y="0"/>
+          <a:ext cx="0" cy="0"/>
+          <a:chOff x="0" y="0"/>
+          <a:chExt cx="0" cy="0"/>
+        </a:xfrm>
+      </p:grpSpPr>
+      <p:cxnSp>
+        <p:nvCxnSpPr>
+          <p:cNvPr id="41" name="Straight Connector 40"/>
+          <p:cNvCxnSpPr/>
+          <p:nvPr/>
+        </p:nvCxnSpPr>
+        <p:spPr>
+          <a:xfrm>
+            <a:off x="2724600" y="1295400"/>
+            <a:ext cx="0" cy="4104000"/>
+          </a:xfrm>
+          <a:prstGeom prst="line">
+            <a:avLst/>
+          </a:prstGeom>
+          <a:ln>
+            <a:solidFill>
+              <a:schemeClr val="bg1">
+                <a:lumMod val="75000"/>
+              </a:schemeClr>
+            </a:solidFill>
+            <a:prstDash val="sysDot"/>
+          </a:ln>
+        </p:spPr>
+        <p:style>
+          <a:lnRef idx="1">
+            <a:schemeClr val="accent1"/>
+          </a:lnRef>
+          <a:fillRef idx="0">
+            <a:schemeClr val="accent1"/>
+          </a:fillRef>
+          <a:effectRef idx="0">
+            <a:schemeClr val="accent1"/>
+          </a:effectRef>
+          <a:fontRef idx="minor">
+            <a:schemeClr val="tx1"/>
+          </a:fontRef>
+        </p:style>
+      </p:cxnSp>
+      <p:cxnSp>
+        <p:nvCxnSpPr>
+          <p:cNvPr id="42" name="Straight Connector 41"/>
+          <p:cNvCxnSpPr/>
+          <p:nvPr/>
+        </p:nvCxnSpPr>
+        <p:spPr>
+          <a:xfrm>
+            <a:off x="3444600" y="1295400"/>
+            <a:ext cx="0" cy="4104000"/>
+          </a:xfrm>
+          <a:prstGeom prst="line">
+            <a:avLst/>
+          </a:prstGeom>
+          <a:ln>
+            <a:solidFill>
+              <a:schemeClr val="bg1">
+                <a:lumMod val="75000"/>
+              </a:schemeClr>
+            </a:solidFill>
+            <a:prstDash val="sysDot"/>
+          </a:ln>
+        </p:spPr>
+        <p:style>
+          <a:lnRef idx="1">
+            <a:schemeClr val="accent1"/>
+          </a:lnRef>
+          <a:fillRef idx="0">
+            <a:schemeClr val="accent1"/>
+          </a:fillRef>
+          <a:effectRef idx="0">
+            <a:schemeClr val="accent1"/>
+          </a:effectRef>
+          <a:fontRef idx="minor">
+            <a:schemeClr val="tx1"/>
+          </a:fontRef>
+        </p:style>
+      </p:cxnSp>
+      <p:cxnSp>
+        <p:nvCxnSpPr>
+          <p:cNvPr id="43" name="Straight Connector 42"/>
+          <p:cNvCxnSpPr/>
+          <p:nvPr/>
+        </p:nvCxnSpPr>
+        <p:spPr>
+          <a:xfrm>
+            <a:off x="4164600" y="1295400"/>
+            <a:ext cx="0" cy="4104000"/>
+          </a:xfrm>
+          <a:prstGeom prst="line">
+            <a:avLst/>
+          </a:prstGeom>
+          <a:ln>
+            <a:solidFill>
+              <a:schemeClr val="bg1">
+                <a:lumMod val="75000"/>
+              </a:schemeClr>
+            </a:solidFill>
+            <a:prstDash val="sysDot"/>
+          </a:ln>
+        </p:spPr>
+        <p:style>
+          <a:lnRef idx="1">
+            <a:schemeClr val="accent1"/>
+          </a:lnRef>
+          <a:fillRef idx="0">
+            <a:schemeClr val="accent1"/>
+          </a:fillRef>
+          <a:effectRef idx="0">
+            <a:schemeClr val="accent1"/>
+          </a:effectRef>
+          <a:fontRef idx="minor">
+            <a:schemeClr val="tx1"/>
+          </a:fontRef>
+        </p:style>
+      </p:cxnSp>
+      <p:cxnSp>
+        <p:nvCxnSpPr>
+          <p:cNvPr id="44" name="Straight Connector 43"/>
+          <p:cNvCxnSpPr/>
+          <p:nvPr/>
+        </p:nvCxnSpPr>
+        <p:spPr>
+          <a:xfrm>
+            <a:off x="4884600" y="1295400"/>
+            <a:ext cx="0" cy="4104000"/>
+          </a:xfrm>
+          <a:prstGeom prst="line">
+            <a:avLst/>
+          </a:prstGeom>
+          <a:ln>
+            <a:solidFill>
+              <a:schemeClr val="bg1">
+                <a:lumMod val="75000"/>
+              </a:schemeClr>
+            </a:solidFill>
+            <a:prstDash val="sysDot"/>
+          </a:ln>
+        </p:spPr>
+        <p:style>
+          <a:lnRef idx="1">
+            <a:schemeClr val="accent1"/>
+          </a:lnRef>
+          <a:fillRef idx="0">
+            <a:schemeClr val="accent1"/>
+          </a:fillRef>
+          <a:effectRef idx="0">
+            <a:schemeClr val="accent1"/>
+          </a:effectRef>
+          <a:fontRef idx="minor">
+            <a:schemeClr val="tx1"/>
+          </a:fontRef>
+        </p:style>
+      </p:cxnSp>
+      <p:cxnSp>
+        <p:nvCxnSpPr>
+          <p:cNvPr id="45" name="Straight Connector 44"/>
+          <p:cNvCxnSpPr/>
+          <p:nvPr/>
+        </p:nvCxnSpPr>
+        <p:spPr>
+          <a:xfrm>
+            <a:off x="5604600" y="1295400"/>
+            <a:ext cx="0" cy="4104000"/>
+          </a:xfrm>
+          <a:prstGeom prst="line">
+            <a:avLst/>
+          </a:prstGeom>
+          <a:ln>
+            <a:solidFill>
+              <a:schemeClr val="bg1">
+                <a:lumMod val="75000"/>
+              </a:schemeClr>
+            </a:solidFill>
+            <a:prstDash val="sysDot"/>
+          </a:ln>
+        </p:spPr>
+        <p:style>
+          <a:lnRef idx="1">
+            <a:schemeClr val="accent1"/>
+          </a:lnRef>
+          <a:fillRef idx="0">
+            <a:schemeClr val="accent1"/>
+          </a:fillRef>
+          <a:effectRef idx="0">
+            <a:schemeClr val="accent1"/>
+          </a:effectRef>
+          <a:fontRef idx="minor">
+            <a:schemeClr val="tx1"/>
+          </a:fontRef>
+        </p:style>
+      </p:cxnSp>
+      <p:cxnSp>
+        <p:nvCxnSpPr>
+          <p:cNvPr id="18" name="Straight Connector 17"/>
+          <p:cNvCxnSpPr/>
+          <p:nvPr/>
+        </p:nvCxnSpPr>
+        <p:spPr>
+          <a:xfrm>
+            <a:off x="2724600" y="1600200"/>
+            <a:ext cx="360000" cy="0"/>
+          </a:xfrm>
+          <a:prstGeom prst="line">
+            <a:avLst/>
+          </a:prstGeom>
+        </p:spPr>
+        <p:style>
+          <a:lnRef idx="1">
+            <a:schemeClr val="accent1"/>
+          </a:lnRef>
+          <a:fillRef idx="0">
+            <a:schemeClr val="accent1"/>
+          </a:fillRef>
+          <a:effectRef idx="0">
+            <a:schemeClr val="accent1"/>
+          </a:effectRef>
+          <a:fontRef idx="minor">
+            <a:schemeClr val="tx1"/>
+          </a:fontRef>
+        </p:style>
+      </p:cxnSp>
+      <p:cxnSp>
+        <p:nvCxnSpPr>
+          <p:cNvPr id="21" name="Straight Connector 20"/>
+          <p:cNvCxnSpPr/>
+          <p:nvPr/>
+        </p:nvCxnSpPr>
+        <p:spPr>
+          <a:xfrm>
+            <a:off x="2724600" y="1600200"/>
+            <a:ext cx="0" cy="360000"/>
+          </a:xfrm>
+          <a:prstGeom prst="line">
+            <a:avLst/>
+          </a:prstGeom>
+        </p:spPr>
+        <p:style>
+          <a:lnRef idx="1">
+            <a:schemeClr val="accent1"/>
+          </a:lnRef>
+          <a:fillRef idx="0">
+            <a:schemeClr val="accent1"/>
+          </a:fillRef>
+          <a:effectRef idx="0">
+            <a:schemeClr val="accent1"/>
+          </a:effectRef>
+          <a:fontRef idx="minor">
+            <a:schemeClr val="tx1"/>
+          </a:fontRef>
+        </p:style>
+      </p:cxnSp>
+      <p:cxnSp>
+        <p:nvCxnSpPr>
+          <p:cNvPr id="22" name="Straight Connector 21"/>
+          <p:cNvCxnSpPr/>
+          <p:nvPr/>
+        </p:nvCxnSpPr>
+        <p:spPr>
+          <a:xfrm>
+            <a:off x="3084600" y="1600200"/>
+            <a:ext cx="0" cy="360000"/>
+          </a:xfrm>
+          <a:prstGeom prst="line">
+            <a:avLst/>
+          </a:prstGeom>
+        </p:spPr>
+        <p:style>
+          <a:lnRef idx="1">
+            <a:schemeClr val="accent1"/>
+          </a:lnRef>
+          <a:fillRef idx="0">
+            <a:schemeClr val="accent1"/>
+          </a:fillRef>
+          <a:effectRef idx="0">
+            <a:schemeClr val="accent1"/>
+          </a:effectRef>
+          <a:fontRef idx="minor">
+            <a:schemeClr val="tx1"/>
+          </a:fontRef>
+        </p:style>
+      </p:cxnSp>
+      <p:cxnSp>
+        <p:nvCxnSpPr>
+          <p:cNvPr id="23" name="Straight Connector 22"/>
+          <p:cNvCxnSpPr/>
+          <p:nvPr/>
+        </p:nvCxnSpPr>
+        <p:spPr>
+          <a:xfrm>
+            <a:off x="3084600" y="1960200"/>
+            <a:ext cx="360000" cy="0"/>
+          </a:xfrm>
+          <a:prstGeom prst="line">
+            <a:avLst/>
+          </a:prstGeom>
+        </p:spPr>
+        <p:style>
+          <a:lnRef idx="1">
+            <a:schemeClr val="accent1"/>
+          </a:lnRef>
+          <a:fillRef idx="0">
+            <a:schemeClr val="accent1"/>
+          </a:fillRef>
+          <a:effectRef idx="0">
+            <a:schemeClr val="accent1"/>
+          </a:effectRef>
+          <a:fontRef idx="minor">
+            <a:schemeClr val="tx1"/>
+          </a:fontRef>
+        </p:style>
+      </p:cxnSp>
+      <p:cxnSp>
+        <p:nvCxnSpPr>
+          <p:cNvPr id="24" name="Straight Connector 23"/>
+          <p:cNvCxnSpPr/>
+          <p:nvPr/>
+        </p:nvCxnSpPr>
+        <p:spPr>
+          <a:xfrm>
+            <a:off x="3444600" y="1600200"/>
+            <a:ext cx="360000" cy="0"/>
+          </a:xfrm>
+          <a:prstGeom prst="line">
+            <a:avLst/>
+          </a:prstGeom>
+        </p:spPr>
+        <p:style>
+          <a:lnRef idx="1">
+            <a:schemeClr val="accent1"/>
+          </a:lnRef>
+          <a:fillRef idx="0">
+            <a:schemeClr val="accent1"/>
+          </a:fillRef>
+          <a:effectRef idx="0">
+            <a:schemeClr val="accent1"/>
+          </a:effectRef>
+          <a:fontRef idx="minor">
+            <a:schemeClr val="tx1"/>
+          </a:fontRef>
+        </p:style>
+      </p:cxnSp>
+      <p:cxnSp>
+        <p:nvCxnSpPr>
+          <p:cNvPr id="25" name="Straight Connector 24"/>
+          <p:cNvCxnSpPr/>
+          <p:nvPr/>
+        </p:nvCxnSpPr>
+        <p:spPr>
+          <a:xfrm>
+            <a:off x="3444600" y="1600200"/>
+            <a:ext cx="0" cy="360000"/>
+          </a:xfrm>
+          <a:prstGeom prst="line">
+            <a:avLst/>
+          </a:prstGeom>
+        </p:spPr>
+        <p:style>
+          <a:lnRef idx="1">
+            <a:schemeClr val="accent1"/>
+          </a:lnRef>
+          <a:fillRef idx="0">
+            <a:schemeClr val="accent1"/>
+          </a:fillRef>
+          <a:effectRef idx="0">
+            <a:schemeClr val="accent1"/>
+          </a:effectRef>
+          <a:fontRef idx="minor">
+            <a:schemeClr val="tx1"/>
+          </a:fontRef>
+        </p:style>
+      </p:cxnSp>
+      <p:cxnSp>
+        <p:nvCxnSpPr>
+          <p:cNvPr id="26" name="Straight Connector 25"/>
+          <p:cNvCxnSpPr/>
+          <p:nvPr/>
+        </p:nvCxnSpPr>
+        <p:spPr>
+          <a:xfrm>
+            <a:off x="3804600" y="1600200"/>
+            <a:ext cx="0" cy="360000"/>
+          </a:xfrm>
+          <a:prstGeom prst="line">
+            <a:avLst/>
+          </a:prstGeom>
+        </p:spPr>
+        <p:style>
+          <a:lnRef idx="1">
+            <a:schemeClr val="accent1"/>
+          </a:lnRef>
+          <a:fillRef idx="0">
+            <a:schemeClr val="accent1"/>
+          </a:fillRef>
+          <a:effectRef idx="0">
+            <a:schemeClr val="accent1"/>
+          </a:effectRef>
+          <a:fontRef idx="minor">
+            <a:schemeClr val="tx1"/>
+          </a:fontRef>
+        </p:style>
+      </p:cxnSp>
+      <p:cxnSp>
+        <p:nvCxnSpPr>
+          <p:cNvPr id="27" name="Straight Connector 26"/>
+          <p:cNvCxnSpPr/>
+          <p:nvPr/>
+        </p:nvCxnSpPr>
+        <p:spPr>
+          <a:xfrm>
+            <a:off x="3804600" y="1960200"/>
+            <a:ext cx="360000" cy="0"/>
+          </a:xfrm>
+          <a:prstGeom prst="line">
+            <a:avLst/>
+          </a:prstGeom>
+        </p:spPr>
+        <p:style>
+          <a:lnRef idx="1">
+            <a:schemeClr val="accent1"/>
+          </a:lnRef>
+          <a:fillRef idx="0">
+            <a:schemeClr val="accent1"/>
+          </a:fillRef>
+          <a:effectRef idx="0">
+            <a:schemeClr val="accent1"/>
+          </a:effectRef>
+          <a:fontRef idx="minor">
+            <a:schemeClr val="tx1"/>
+          </a:fontRef>
+        </p:style>
+      </p:cxnSp>
+      <p:cxnSp>
+        <p:nvCxnSpPr>
+          <p:cNvPr id="28" name="Straight Connector 27"/>
+          <p:cNvCxnSpPr/>
+          <p:nvPr/>
+        </p:nvCxnSpPr>
+        <p:spPr>
+          <a:xfrm>
+            <a:off x="4164600" y="1600200"/>
+            <a:ext cx="360000" cy="0"/>
+          </a:xfrm>
+          <a:prstGeom prst="line">
+            <a:avLst/>
+          </a:prstGeom>
+        </p:spPr>
+        <p:style>
+          <a:lnRef idx="1">
+            <a:schemeClr val="accent1"/>
+          </a:lnRef>
+          <a:fillRef idx="0">
+            <a:schemeClr val="accent1"/>
+          </a:fillRef>
+          <a:effectRef idx="0">
+            <a:schemeClr val="accent1"/>
+          </a:effectRef>
+          <a:fontRef idx="minor">
+            <a:schemeClr val="tx1"/>
+          </a:fontRef>
+        </p:style>
+      </p:cxnSp>
+      <p:cxnSp>
+        <p:nvCxnSpPr>
+          <p:cNvPr id="29" name="Straight Connector 28"/>
+          <p:cNvCxnSpPr/>
+          <p:nvPr/>
+        </p:nvCxnSpPr>
+        <p:spPr>
+          <a:xfrm>
+            <a:off x="4164600" y="1600200"/>
+            <a:ext cx="0" cy="360000"/>
+          </a:xfrm>
+          <a:prstGeom prst="line">
+            <a:avLst/>
+          </a:prstGeom>
+        </p:spPr>
+        <p:style>
+          <a:lnRef idx="1">
+            <a:schemeClr val="accent1"/>
+          </a:lnRef>
+          <a:fillRef idx="0">
+            <a:schemeClr val="accent1"/>
+          </a:fillRef>
+          <a:effectRef idx="0">
+            <a:schemeClr val="accent1"/>
+          </a:effectRef>
+          <a:fontRef idx="minor">
+            <a:schemeClr val="tx1"/>
+          </a:fontRef>
+        </p:style>
+      </p:cxnSp>
+      <p:cxnSp>
+        <p:nvCxnSpPr>
+          <p:cNvPr id="30" name="Straight Connector 29"/>
+          <p:cNvCxnSpPr/>
+          <p:nvPr/>
+        </p:nvCxnSpPr>
+        <p:spPr>
+          <a:xfrm>
+            <a:off x="4524600" y="1600200"/>
+            <a:ext cx="0" cy="360000"/>
+          </a:xfrm>
+          <a:prstGeom prst="line">
+            <a:avLst/>
+          </a:prstGeom>
+        </p:spPr>
+        <p:style>
+          <a:lnRef idx="1">
+            <a:schemeClr val="accent1"/>
+          </a:lnRef>
+          <a:fillRef idx="0">
+            <a:schemeClr val="accent1"/>
+          </a:fillRef>
+          <a:effectRef idx="0">
+            <a:schemeClr val="accent1"/>
+          </a:effectRef>
+          <a:fontRef idx="minor">
+            <a:schemeClr val="tx1"/>
+          </a:fontRef>
+        </p:style>
+      </p:cxnSp>
+      <p:cxnSp>
+        <p:nvCxnSpPr>
+          <p:cNvPr id="31" name="Straight Connector 30"/>
+          <p:cNvCxnSpPr/>
+          <p:nvPr/>
+        </p:nvCxnSpPr>
+        <p:spPr>
+          <a:xfrm>
+            <a:off x="4524600" y="1960200"/>
+            <a:ext cx="360000" cy="0"/>
+          </a:xfrm>
+          <a:prstGeom prst="line">
+            <a:avLst/>
+          </a:prstGeom>
+        </p:spPr>
+        <p:style>
+          <a:lnRef idx="1">
+            <a:schemeClr val="accent1"/>
+          </a:lnRef>
+          <a:fillRef idx="0">
+            <a:schemeClr val="accent1"/>
+          </a:fillRef>
+          <a:effectRef idx="0">
+            <a:schemeClr val="accent1"/>
+          </a:effectRef>
+          <a:fontRef idx="minor">
+            <a:schemeClr val="tx1"/>
+          </a:fontRef>
+        </p:style>
+      </p:cxnSp>
+      <p:cxnSp>
+        <p:nvCxnSpPr>
+          <p:cNvPr id="32" name="Straight Connector 31"/>
+          <p:cNvCxnSpPr/>
+          <p:nvPr/>
+        </p:nvCxnSpPr>
+        <p:spPr>
+          <a:xfrm>
+            <a:off x="4884600" y="1600200"/>
+            <a:ext cx="360000" cy="0"/>
+          </a:xfrm>
+          <a:prstGeom prst="line">
+            <a:avLst/>
+          </a:prstGeom>
+        </p:spPr>
+        <p:style>
+          <a:lnRef idx="1">
+            <a:schemeClr val="accent1"/>
+          </a:lnRef>
+          <a:fillRef idx="0">
+            <a:schemeClr val="accent1"/>
+          </a:fillRef>
+          <a:effectRef idx="0">
+            <a:schemeClr val="accent1"/>
+          </a:effectRef>
+          <a:fontRef idx="minor">
+            <a:schemeClr val="tx1"/>
+          </a:fontRef>
+        </p:style>
+      </p:cxnSp>
+      <p:cxnSp>
+        <p:nvCxnSpPr>
+          <p:cNvPr id="33" name="Straight Connector 32"/>
+          <p:cNvCxnSpPr/>
+          <p:nvPr/>
+        </p:nvCxnSpPr>
+        <p:spPr>
+          <a:xfrm>
+            <a:off x="4884600" y="1600200"/>
+            <a:ext cx="0" cy="360000"/>
+          </a:xfrm>
+          <a:prstGeom prst="line">
+            <a:avLst/>
+          </a:prstGeom>
+        </p:spPr>
+        <p:style>
+          <a:lnRef idx="1">
+            <a:schemeClr val="accent1"/>
+          </a:lnRef>
+          <a:fillRef idx="0">
+            <a:schemeClr val="accent1"/>
+          </a:fillRef>
+          <a:effectRef idx="0">
+            <a:schemeClr val="accent1"/>
+          </a:effectRef>
+          <a:fontRef idx="minor">
+            <a:schemeClr val="tx1"/>
+          </a:fontRef>
+        </p:style>
+      </p:cxnSp>
+      <p:cxnSp>
+        <p:nvCxnSpPr>
+          <p:cNvPr id="34" name="Straight Connector 33"/>
+          <p:cNvCxnSpPr/>
+          <p:nvPr/>
+        </p:nvCxnSpPr>
+        <p:spPr>
+          <a:xfrm>
+            <a:off x="5244600" y="1600200"/>
+            <a:ext cx="0" cy="360000"/>
+          </a:xfrm>
+          <a:prstGeom prst="line">
+            <a:avLst/>
+          </a:prstGeom>
+        </p:spPr>
+        <p:style>
+          <a:lnRef idx="1">
+            <a:schemeClr val="accent1"/>
+          </a:lnRef>
+          <a:fillRef idx="0">
+            <a:schemeClr val="accent1"/>
+          </a:fillRef>
+          <a:effectRef idx="0">
+            <a:schemeClr val="accent1"/>
+          </a:effectRef>
+          <a:fontRef idx="minor">
+            <a:schemeClr val="tx1"/>
+          </a:fontRef>
+        </p:style>
+      </p:cxnSp>
+      <p:cxnSp>
+        <p:nvCxnSpPr>
+          <p:cNvPr id="35" name="Straight Connector 34"/>
+          <p:cNvCxnSpPr/>
+          <p:nvPr/>
+        </p:nvCxnSpPr>
+        <p:spPr>
+          <a:xfrm>
+            <a:off x="5244600" y="1960200"/>
+            <a:ext cx="360000" cy="0"/>
+          </a:xfrm>
+          <a:prstGeom prst="line">
+            <a:avLst/>
+          </a:prstGeom>
+        </p:spPr>
+        <p:style>
+          <a:lnRef idx="1">
+            <a:schemeClr val="accent1"/>
+          </a:lnRef>
+          <a:fillRef idx="0">
+            <a:schemeClr val="accent1"/>
+          </a:fillRef>
+          <a:effectRef idx="0">
+            <a:schemeClr val="accent1"/>
+          </a:effectRef>
+          <a:fontRef idx="minor">
+            <a:schemeClr val="tx1"/>
+          </a:fontRef>
+        </p:style>
+      </p:cxnSp>
+      <p:cxnSp>
+        <p:nvCxnSpPr>
+          <p:cNvPr id="37" name="Straight Connector 36"/>
+          <p:cNvCxnSpPr/>
+          <p:nvPr/>
+        </p:nvCxnSpPr>
+        <p:spPr>
+          <a:xfrm>
+            <a:off x="5604600" y="1600200"/>
+            <a:ext cx="0" cy="360000"/>
+          </a:xfrm>
+          <a:prstGeom prst="line">
+            <a:avLst/>
+          </a:prstGeom>
+        </p:spPr>
+        <p:style>
+          <a:lnRef idx="1">
+            <a:schemeClr val="accent1"/>
+          </a:lnRef>
+          <a:fillRef idx="0">
+            <a:schemeClr val="accent1"/>
+          </a:fillRef>
+          <a:effectRef idx="0">
+            <a:schemeClr val="accent1"/>
+          </a:effectRef>
+          <a:fontRef idx="minor">
+            <a:schemeClr val="tx1"/>
+          </a:fontRef>
+        </p:style>
+      </p:cxnSp>
+      <p:sp>
+        <p:nvSpPr>
+          <p:cNvPr id="46" name="TextBox 45"/>
+          <p:cNvSpPr txBox="1"/>
+          <p:nvPr/>
+        </p:nvSpPr>
+        <p:spPr>
+          <a:xfrm>
+            <a:off x="2032746" y="1600200"/>
+            <a:ext cx="728405" cy="338554"/>
+          </a:xfrm>
+          <a:prstGeom prst="rect">
+            <a:avLst/>
+          </a:prstGeom>
+          <a:noFill/>
+        </p:spPr>
+        <p:txBody>
+          <a:bodyPr wrap="none" rtlCol="0">
+            <a:spAutoFit/>
+          </a:bodyPr>
+          <a:lstStyle/>
+          <a:p>
+            <a:r>
+              <a:rPr lang="en-GB" sz="1600" dirty="0" smtClean="0"/>
+              <a:t>CLOCK</a:t>
+            </a:r>
+            <a:endParaRPr lang="en-GB" sz="1600" dirty="0"/>
+          </a:p>
+        </p:txBody>
+      </p:sp>
+      <p:sp>
+        <p:nvSpPr>
+          <p:cNvPr id="53" name="TextBox 52"/>
+          <p:cNvSpPr txBox="1"/>
+          <p:nvPr/>
+        </p:nvSpPr>
+        <p:spPr>
+          <a:xfrm>
+            <a:off x="2029861" y="2248769"/>
+            <a:ext cx="731290" cy="338554"/>
+          </a:xfrm>
+          <a:prstGeom prst="rect">
+            <a:avLst/>
+          </a:prstGeom>
+          <a:noFill/>
+        </p:spPr>
+        <p:txBody>
+          <a:bodyPr wrap="none" rtlCol="0">
+            <a:spAutoFit/>
+          </a:bodyPr>
+          <a:lstStyle/>
+          <a:p>
+            <a:r>
+              <a:rPr lang="en-GB" sz="1600" dirty="0" smtClean="0"/>
+              <a:t>WRITE</a:t>
+            </a:r>
+            <a:endParaRPr lang="en-GB" sz="1600" dirty="0"/>
+          </a:p>
+        </p:txBody>
+      </p:sp>
+      <p:sp>
+        <p:nvSpPr>
+          <p:cNvPr id="54" name="TextBox 53"/>
+          <p:cNvSpPr txBox="1"/>
+          <p:nvPr/>
+        </p:nvSpPr>
+        <p:spPr>
+          <a:xfrm>
+            <a:off x="1052029" y="2897338"/>
+            <a:ext cx="1709122" cy="338554"/>
+          </a:xfrm>
+          <a:prstGeom prst="rect">
+            <a:avLst/>
+          </a:prstGeom>
+          <a:noFill/>
+        </p:spPr>
+        <p:txBody>
+          <a:bodyPr wrap="none" rtlCol="0">
+            <a:spAutoFit/>
+          </a:bodyPr>
+          <a:lstStyle/>
+          <a:p>
+            <a:r>
+              <a:rPr lang="en-GB" sz="1600" dirty="0" smtClean="0"/>
+              <a:t>SELECT &lt;SOURCE&gt;</a:t>
+            </a:r>
+            <a:endParaRPr lang="en-GB" sz="1600" dirty="0"/>
+          </a:p>
+        </p:txBody>
+      </p:sp>
+      <p:sp>
+        <p:nvSpPr>
+          <p:cNvPr id="55" name="TextBox 54"/>
+          <p:cNvSpPr txBox="1"/>
+          <p:nvPr/>
+        </p:nvSpPr>
+        <p:spPr>
+          <a:xfrm>
+            <a:off x="2120206" y="4194476"/>
+            <a:ext cx="640945" cy="338554"/>
+          </a:xfrm>
+          <a:prstGeom prst="rect">
+            <a:avLst/>
+          </a:prstGeom>
+          <a:noFill/>
+        </p:spPr>
+        <p:txBody>
+          <a:bodyPr wrap="none" rtlCol="0">
+            <a:spAutoFit/>
+          </a:bodyPr>
+          <a:lstStyle/>
+          <a:p>
+            <a:r>
+              <a:rPr lang="en-GB" sz="1600" dirty="0" smtClean="0"/>
+              <a:t>READ</a:t>
+            </a:r>
+            <a:endParaRPr lang="en-GB" sz="1600" dirty="0"/>
+          </a:p>
+        </p:txBody>
+      </p:sp>
+      <p:sp>
+        <p:nvSpPr>
+          <p:cNvPr id="56" name="TextBox 55"/>
+          <p:cNvSpPr txBox="1"/>
+          <p:nvPr/>
+        </p:nvSpPr>
+        <p:spPr>
+          <a:xfrm>
+            <a:off x="609600" y="4843046"/>
+            <a:ext cx="2151551" cy="338554"/>
+          </a:xfrm>
+          <a:prstGeom prst="rect">
+            <a:avLst/>
+          </a:prstGeom>
+          <a:noFill/>
+        </p:spPr>
+        <p:txBody>
+          <a:bodyPr wrap="none" rtlCol="0">
+            <a:spAutoFit/>
+          </a:bodyPr>
+          <a:lstStyle/>
+          <a:p>
+            <a:r>
+              <a:rPr lang="en-GB" sz="1600" dirty="0" smtClean="0"/>
+              <a:t>SELECT &lt;DESTINATION&gt;</a:t>
+            </a:r>
+            <a:endParaRPr lang="en-GB" sz="1600" dirty="0"/>
+          </a:p>
+        </p:txBody>
+      </p:sp>
+      <p:cxnSp>
+        <p:nvCxnSpPr>
+          <p:cNvPr id="57" name="Straight Connector 56"/>
+          <p:cNvCxnSpPr/>
+          <p:nvPr/>
+        </p:nvCxnSpPr>
+        <p:spPr>
+          <a:xfrm>
+            <a:off x="2724600" y="2604480"/>
+            <a:ext cx="781200" cy="0"/>
+          </a:xfrm>
+          <a:prstGeom prst="line">
+            <a:avLst/>
+          </a:prstGeom>
+        </p:spPr>
+        <p:style>
+          <a:lnRef idx="1">
+            <a:schemeClr val="accent1"/>
+          </a:lnRef>
+          <a:fillRef idx="0">
+            <a:schemeClr val="accent1"/>
+          </a:fillRef>
+          <a:effectRef idx="0">
+            <a:schemeClr val="accent1"/>
+          </a:effectRef>
+          <a:fontRef idx="minor">
+            <a:schemeClr val="tx1"/>
+          </a:fontRef>
+        </p:style>
+      </p:cxnSp>
+      <p:cxnSp>
+        <p:nvCxnSpPr>
+          <p:cNvPr id="58" name="Straight Connector 57"/>
+          <p:cNvCxnSpPr/>
+          <p:nvPr/>
+        </p:nvCxnSpPr>
+        <p:spPr>
+          <a:xfrm>
+            <a:off x="3505200" y="2244480"/>
+            <a:ext cx="0" cy="360000"/>
+          </a:xfrm>
+          <a:prstGeom prst="line">
+            <a:avLst/>
+          </a:prstGeom>
+        </p:spPr>
+        <p:style>
+          <a:lnRef idx="1">
+            <a:schemeClr val="accent1"/>
+          </a:lnRef>
+          <a:fillRef idx="0">
+            <a:schemeClr val="accent1"/>
+          </a:fillRef>
+          <a:effectRef idx="0">
+            <a:schemeClr val="accent1"/>
+          </a:effectRef>
+          <a:fontRef idx="minor">
+            <a:schemeClr val="tx1"/>
+          </a:fontRef>
+        </p:style>
+      </p:cxnSp>
+      <p:cxnSp>
+        <p:nvCxnSpPr>
+          <p:cNvPr id="59" name="Straight Connector 58"/>
+          <p:cNvCxnSpPr/>
+          <p:nvPr/>
+        </p:nvCxnSpPr>
+        <p:spPr>
+          <a:xfrm>
+            <a:off x="4946400" y="2244480"/>
+            <a:ext cx="0" cy="360000"/>
+          </a:xfrm>
+          <a:prstGeom prst="line">
+            <a:avLst/>
+          </a:prstGeom>
+        </p:spPr>
+        <p:style>
+          <a:lnRef idx="1">
+            <a:schemeClr val="accent1"/>
+          </a:lnRef>
+          <a:fillRef idx="0">
+            <a:schemeClr val="accent1"/>
+          </a:fillRef>
+          <a:effectRef idx="0">
+            <a:schemeClr val="accent1"/>
+          </a:effectRef>
+          <a:fontRef idx="minor">
+            <a:schemeClr val="tx1"/>
+          </a:fontRef>
+        </p:style>
+      </p:cxnSp>
+      <p:cxnSp>
+        <p:nvCxnSpPr>
+          <p:cNvPr id="60" name="Straight Connector 59"/>
+          <p:cNvCxnSpPr/>
+          <p:nvPr/>
+        </p:nvCxnSpPr>
+        <p:spPr>
+          <a:xfrm>
+            <a:off x="3505200" y="2244480"/>
+            <a:ext cx="1440000" cy="0"/>
+          </a:xfrm>
+          <a:prstGeom prst="line">
+            <a:avLst/>
+          </a:prstGeom>
+        </p:spPr>
+        <p:style>
+          <a:lnRef idx="1">
+            <a:schemeClr val="accent1"/>
+          </a:lnRef>
+          <a:fillRef idx="0">
+            <a:schemeClr val="accent1"/>
+          </a:fillRef>
+          <a:effectRef idx="0">
+            <a:schemeClr val="accent1"/>
+          </a:effectRef>
+          <a:fontRef idx="minor">
+            <a:schemeClr val="tx1"/>
+          </a:fontRef>
+        </p:style>
+      </p:cxnSp>
+      <p:cxnSp>
+        <p:nvCxnSpPr>
+          <p:cNvPr id="62" name="Straight Connector 61"/>
+          <p:cNvCxnSpPr/>
+          <p:nvPr/>
+        </p:nvCxnSpPr>
+        <p:spPr>
+          <a:xfrm>
+            <a:off x="4946400" y="2604480"/>
+            <a:ext cx="658800" cy="0"/>
+          </a:xfrm>
+          <a:prstGeom prst="line">
+            <a:avLst/>
+          </a:prstGeom>
+        </p:spPr>
+        <p:style>
+          <a:lnRef idx="1">
+            <a:schemeClr val="accent1"/>
+          </a:lnRef>
+          <a:fillRef idx="0">
+            <a:schemeClr val="accent1"/>
+          </a:fillRef>
+          <a:effectRef idx="0">
+            <a:schemeClr val="accent1"/>
+          </a:effectRef>
+          <a:fontRef idx="minor">
+            <a:schemeClr val="tx1"/>
+          </a:fontRef>
+        </p:style>
+      </p:cxnSp>
+      <p:cxnSp>
+        <p:nvCxnSpPr>
+          <p:cNvPr id="63" name="Straight Connector 62"/>
+          <p:cNvCxnSpPr/>
+          <p:nvPr/>
+        </p:nvCxnSpPr>
+        <p:spPr>
+          <a:xfrm>
+            <a:off x="2724600" y="3248760"/>
+            <a:ext cx="781200" cy="0"/>
+          </a:xfrm>
+          <a:prstGeom prst="line">
+            <a:avLst/>
+          </a:prstGeom>
+        </p:spPr>
+        <p:style>
+          <a:lnRef idx="1">
+            <a:schemeClr val="accent1"/>
+          </a:lnRef>
+          <a:fillRef idx="0">
+            <a:schemeClr val="accent1"/>
+          </a:fillRef>
+          <a:effectRef idx="0">
+            <a:schemeClr val="accent1"/>
+          </a:effectRef>
+          <a:fontRef idx="minor">
+            <a:schemeClr val="tx1"/>
+          </a:fontRef>
+        </p:style>
+      </p:cxnSp>
+      <p:cxnSp>
+        <p:nvCxnSpPr>
+          <p:cNvPr id="64" name="Straight Connector 63"/>
+          <p:cNvCxnSpPr/>
+          <p:nvPr/>
+        </p:nvCxnSpPr>
+        <p:spPr>
+          <a:xfrm>
+            <a:off x="3505200" y="2888760"/>
+            <a:ext cx="0" cy="360000"/>
+          </a:xfrm>
+          <a:prstGeom prst="line">
+            <a:avLst/>
+          </a:prstGeom>
+        </p:spPr>
+        <p:style>
+          <a:lnRef idx="1">
+            <a:schemeClr val="accent1"/>
+          </a:lnRef>
+          <a:fillRef idx="0">
+            <a:schemeClr val="accent1"/>
+          </a:fillRef>
+          <a:effectRef idx="0">
+            <a:schemeClr val="accent1"/>
+          </a:effectRef>
+          <a:fontRef idx="minor">
+            <a:schemeClr val="tx1"/>
+          </a:fontRef>
+        </p:style>
+      </p:cxnSp>
+      <p:cxnSp>
+        <p:nvCxnSpPr>
+          <p:cNvPr id="65" name="Straight Connector 64"/>
+          <p:cNvCxnSpPr/>
+          <p:nvPr/>
+        </p:nvCxnSpPr>
+        <p:spPr>
+          <a:xfrm>
+            <a:off x="4946400" y="2888760"/>
+            <a:ext cx="0" cy="360000"/>
+          </a:xfrm>
+          <a:prstGeom prst="line">
+            <a:avLst/>
+          </a:prstGeom>
+        </p:spPr>
+        <p:style>
+          <a:lnRef idx="1">
+            <a:schemeClr val="accent1"/>
+          </a:lnRef>
+          <a:fillRef idx="0">
+            <a:schemeClr val="accent1"/>
+          </a:fillRef>
+          <a:effectRef idx="0">
+            <a:schemeClr val="accent1"/>
+          </a:effectRef>
+          <a:fontRef idx="minor">
+            <a:schemeClr val="tx1"/>
+          </a:fontRef>
+        </p:style>
+      </p:cxnSp>
+      <p:cxnSp>
+        <p:nvCxnSpPr>
+          <p:cNvPr id="66" name="Straight Connector 65"/>
+          <p:cNvCxnSpPr/>
+          <p:nvPr/>
+        </p:nvCxnSpPr>
+        <p:spPr>
+          <a:xfrm>
+            <a:off x="3505200" y="2888760"/>
+            <a:ext cx="1440000" cy="0"/>
+          </a:xfrm>
+          <a:prstGeom prst="line">
+            <a:avLst/>
+          </a:prstGeom>
+        </p:spPr>
+        <p:style>
+          <a:lnRef idx="1">
+            <a:schemeClr val="accent1"/>
+          </a:lnRef>
+          <a:fillRef idx="0">
+            <a:schemeClr val="accent1"/>
+          </a:fillRef>
+          <a:effectRef idx="0">
+            <a:schemeClr val="accent1"/>
+          </a:effectRef>
+          <a:fontRef idx="minor">
+            <a:schemeClr val="tx1"/>
+          </a:fontRef>
+        </p:style>
+      </p:cxnSp>
+      <p:cxnSp>
+        <p:nvCxnSpPr>
+          <p:cNvPr id="67" name="Straight Connector 66"/>
+          <p:cNvCxnSpPr/>
+          <p:nvPr/>
+        </p:nvCxnSpPr>
+        <p:spPr>
+          <a:xfrm>
+            <a:off x="4946400" y="3248760"/>
+            <a:ext cx="658800" cy="0"/>
+          </a:xfrm>
+          <a:prstGeom prst="line">
+            <a:avLst/>
+          </a:prstGeom>
+        </p:spPr>
+        <p:style>
+          <a:lnRef idx="1">
+            <a:schemeClr val="accent1"/>
+          </a:lnRef>
+          <a:fillRef idx="0">
+            <a:schemeClr val="accent1"/>
+          </a:fillRef>
+          <a:effectRef idx="0">
+            <a:schemeClr val="accent1"/>
+          </a:effectRef>
+          <a:fontRef idx="minor">
+            <a:schemeClr val="tx1"/>
+          </a:fontRef>
+        </p:style>
+      </p:cxnSp>
+      <p:cxnSp>
+        <p:nvCxnSpPr>
+          <p:cNvPr id="68" name="Straight Connector 67"/>
+          <p:cNvCxnSpPr/>
+          <p:nvPr/>
+        </p:nvCxnSpPr>
+        <p:spPr>
+          <a:xfrm>
+            <a:off x="2724600" y="4537320"/>
+            <a:ext cx="1501200" cy="0"/>
+          </a:xfrm>
+          <a:prstGeom prst="line">
+            <a:avLst/>
+          </a:prstGeom>
+        </p:spPr>
+        <p:style>
+          <a:lnRef idx="1">
+            <a:schemeClr val="accent1"/>
+          </a:lnRef>
+          <a:fillRef idx="0">
+            <a:schemeClr val="accent1"/>
+          </a:fillRef>
+          <a:effectRef idx="0">
+            <a:schemeClr val="accent1"/>
+          </a:effectRef>
+          <a:fontRef idx="minor">
+            <a:schemeClr val="tx1"/>
+          </a:fontRef>
+        </p:style>
+      </p:cxnSp>
+      <p:cxnSp>
+        <p:nvCxnSpPr>
+          <p:cNvPr id="69" name="Straight Connector 68"/>
+          <p:cNvCxnSpPr/>
+          <p:nvPr/>
+        </p:nvCxnSpPr>
+        <p:spPr>
+          <a:xfrm>
+            <a:off x="4225800" y="4177320"/>
+            <a:ext cx="0" cy="360000"/>
+          </a:xfrm>
+          <a:prstGeom prst="line">
+            <a:avLst/>
+          </a:prstGeom>
+        </p:spPr>
+        <p:style>
+          <a:lnRef idx="1">
+            <a:schemeClr val="accent1"/>
+          </a:lnRef>
+          <a:fillRef idx="0">
+            <a:schemeClr val="accent1"/>
+          </a:fillRef>
+          <a:effectRef idx="0">
+            <a:schemeClr val="accent1"/>
+          </a:effectRef>
+          <a:fontRef idx="minor">
+            <a:schemeClr val="tx1"/>
+          </a:fontRef>
+        </p:style>
+      </p:cxnSp>
+      <p:cxnSp>
+        <p:nvCxnSpPr>
+          <p:cNvPr id="70" name="Straight Connector 69"/>
+          <p:cNvCxnSpPr/>
+          <p:nvPr/>
+        </p:nvCxnSpPr>
+        <p:spPr>
+          <a:xfrm>
+            <a:off x="4225800" y="4177320"/>
+            <a:ext cx="720000" cy="0"/>
+          </a:xfrm>
+          <a:prstGeom prst="line">
+            <a:avLst/>
+          </a:prstGeom>
+        </p:spPr>
+        <p:style>
+          <a:lnRef idx="1">
+            <a:schemeClr val="accent1"/>
+          </a:lnRef>
+          <a:fillRef idx="0">
+            <a:schemeClr val="accent1"/>
+          </a:fillRef>
+          <a:effectRef idx="0">
+            <a:schemeClr val="accent1"/>
+          </a:effectRef>
+          <a:fontRef idx="minor">
+            <a:schemeClr val="tx1"/>
+          </a:fontRef>
+        </p:style>
+      </p:cxnSp>
+      <p:cxnSp>
+        <p:nvCxnSpPr>
+          <p:cNvPr id="71" name="Straight Connector 70"/>
+          <p:cNvCxnSpPr/>
+          <p:nvPr/>
+        </p:nvCxnSpPr>
+        <p:spPr>
+          <a:xfrm>
+            <a:off x="4946400" y="4177320"/>
+            <a:ext cx="0" cy="360000"/>
+          </a:xfrm>
+          <a:prstGeom prst="line">
+            <a:avLst/>
+          </a:prstGeom>
+        </p:spPr>
+        <p:style>
+          <a:lnRef idx="1">
+            <a:schemeClr val="accent1"/>
+          </a:lnRef>
+          <a:fillRef idx="0">
+            <a:schemeClr val="accent1"/>
+          </a:fillRef>
+          <a:effectRef idx="0">
+            <a:schemeClr val="accent1"/>
+          </a:effectRef>
+          <a:fontRef idx="minor">
+            <a:schemeClr val="tx1"/>
+          </a:fontRef>
+        </p:style>
+      </p:cxnSp>
+      <p:cxnSp>
+        <p:nvCxnSpPr>
+          <p:cNvPr id="72" name="Straight Connector 71"/>
+          <p:cNvCxnSpPr/>
+          <p:nvPr/>
+        </p:nvCxnSpPr>
+        <p:spPr>
+          <a:xfrm>
+            <a:off x="4946400" y="4537320"/>
+            <a:ext cx="658800" cy="0"/>
+          </a:xfrm>
+          <a:prstGeom prst="line">
+            <a:avLst/>
+          </a:prstGeom>
+        </p:spPr>
+        <p:style>
+          <a:lnRef idx="1">
+            <a:schemeClr val="accent1"/>
+          </a:lnRef>
+          <a:fillRef idx="0">
+            <a:schemeClr val="accent1"/>
+          </a:fillRef>
+          <a:effectRef idx="0">
+            <a:schemeClr val="accent1"/>
+          </a:effectRef>
+          <a:fontRef idx="minor">
+            <a:schemeClr val="tx1"/>
+          </a:fontRef>
+        </p:style>
+      </p:cxnSp>
+      <p:cxnSp>
+        <p:nvCxnSpPr>
+          <p:cNvPr id="73" name="Straight Connector 72"/>
+          <p:cNvCxnSpPr/>
+          <p:nvPr/>
+        </p:nvCxnSpPr>
+        <p:spPr>
+          <a:xfrm>
+            <a:off x="2724000" y="5181600"/>
+            <a:ext cx="1501200" cy="0"/>
+          </a:xfrm>
+          <a:prstGeom prst="line">
+            <a:avLst/>
+          </a:prstGeom>
+        </p:spPr>
+        <p:style>
+          <a:lnRef idx="1">
+            <a:schemeClr val="accent1"/>
+          </a:lnRef>
+          <a:fillRef idx="0">
+            <a:schemeClr val="accent1"/>
+          </a:fillRef>
+          <a:effectRef idx="0">
+            <a:schemeClr val="accent1"/>
+          </a:effectRef>
+          <a:fontRef idx="minor">
+            <a:schemeClr val="tx1"/>
+          </a:fontRef>
+        </p:style>
+      </p:cxnSp>
+      <p:cxnSp>
+        <p:nvCxnSpPr>
+          <p:cNvPr id="74" name="Straight Connector 73"/>
+          <p:cNvCxnSpPr/>
+          <p:nvPr/>
+        </p:nvCxnSpPr>
+        <p:spPr>
+          <a:xfrm>
+            <a:off x="4225200" y="4821600"/>
+            <a:ext cx="0" cy="360000"/>
+          </a:xfrm>
+          <a:prstGeom prst="line">
+            <a:avLst/>
+          </a:prstGeom>
+        </p:spPr>
+        <p:style>
+          <a:lnRef idx="1">
+            <a:schemeClr val="accent1"/>
+          </a:lnRef>
+          <a:fillRef idx="0">
+            <a:schemeClr val="accent1"/>
+          </a:fillRef>
+          <a:effectRef idx="0">
+            <a:schemeClr val="accent1"/>
+          </a:effectRef>
+          <a:fontRef idx="minor">
+            <a:schemeClr val="tx1"/>
+          </a:fontRef>
+        </p:style>
+      </p:cxnSp>
+      <p:cxnSp>
+        <p:nvCxnSpPr>
+          <p:cNvPr id="75" name="Straight Connector 74"/>
+          <p:cNvCxnSpPr/>
+          <p:nvPr/>
+        </p:nvCxnSpPr>
+        <p:spPr>
+          <a:xfrm>
+            <a:off x="4225200" y="4821600"/>
+            <a:ext cx="720000" cy="0"/>
+          </a:xfrm>
+          <a:prstGeom prst="line">
+            <a:avLst/>
+          </a:prstGeom>
+        </p:spPr>
+        <p:style>
+          <a:lnRef idx="1">
+            <a:schemeClr val="accent1"/>
+          </a:lnRef>
+          <a:fillRef idx="0">
+            <a:schemeClr val="accent1"/>
+          </a:fillRef>
+          <a:effectRef idx="0">
+            <a:schemeClr val="accent1"/>
+          </a:effectRef>
+          <a:fontRef idx="minor">
+            <a:schemeClr val="tx1"/>
+          </a:fontRef>
+        </p:style>
+      </p:cxnSp>
+      <p:cxnSp>
+        <p:nvCxnSpPr>
+          <p:cNvPr id="76" name="Straight Connector 75"/>
+          <p:cNvCxnSpPr/>
+          <p:nvPr/>
+        </p:nvCxnSpPr>
+        <p:spPr>
+          <a:xfrm>
+            <a:off x="4945800" y="4821600"/>
+            <a:ext cx="0" cy="360000"/>
+          </a:xfrm>
+          <a:prstGeom prst="line">
+            <a:avLst/>
+          </a:prstGeom>
+        </p:spPr>
+        <p:style>
+          <a:lnRef idx="1">
+            <a:schemeClr val="accent1"/>
+          </a:lnRef>
+          <a:fillRef idx="0">
+            <a:schemeClr val="accent1"/>
+          </a:fillRef>
+          <a:effectRef idx="0">
+            <a:schemeClr val="accent1"/>
+          </a:effectRef>
+          <a:fontRef idx="minor">
+            <a:schemeClr val="tx1"/>
+          </a:fontRef>
+        </p:style>
+      </p:cxnSp>
+      <p:cxnSp>
+        <p:nvCxnSpPr>
+          <p:cNvPr id="77" name="Straight Connector 76"/>
+          <p:cNvCxnSpPr/>
+          <p:nvPr/>
+        </p:nvCxnSpPr>
+        <p:spPr>
+          <a:xfrm>
+            <a:off x="4945800" y="5181600"/>
+            <a:ext cx="658800" cy="0"/>
+          </a:xfrm>
+          <a:prstGeom prst="line">
+            <a:avLst/>
+          </a:prstGeom>
+        </p:spPr>
+        <p:style>
+          <a:lnRef idx="1">
+            <a:schemeClr val="accent1"/>
+          </a:lnRef>
+          <a:fillRef idx="0">
+            <a:schemeClr val="accent1"/>
+          </a:fillRef>
+          <a:effectRef idx="0">
+            <a:schemeClr val="accent1"/>
+          </a:effectRef>
+          <a:fontRef idx="minor">
+            <a:schemeClr val="tx1"/>
+          </a:fontRef>
+        </p:style>
+      </p:cxnSp>
+      <p:cxnSp>
+        <p:nvCxnSpPr>
+          <p:cNvPr id="87" name="Straight Arrow Connector 86"/>
+          <p:cNvCxnSpPr/>
+          <p:nvPr/>
+        </p:nvCxnSpPr>
+        <p:spPr>
+          <a:xfrm>
+            <a:off x="2724600" y="1295400"/>
+            <a:ext cx="720000" cy="0"/>
+          </a:xfrm>
+          <a:prstGeom prst="straightConnector1">
+            <a:avLst/>
+          </a:prstGeom>
+          <a:ln>
+            <a:headEnd type="arrow" w="sm" len="sm"/>
+            <a:tailEnd type="arrow" w="sm" len="sm"/>
+          </a:ln>
+        </p:spPr>
+        <p:style>
+          <a:lnRef idx="1">
+            <a:schemeClr val="accent1"/>
+          </a:lnRef>
+          <a:fillRef idx="0">
+            <a:schemeClr val="accent1"/>
+          </a:fillRef>
+          <a:effectRef idx="0">
+            <a:schemeClr val="accent1"/>
+          </a:effectRef>
+          <a:fontRef idx="minor">
+            <a:schemeClr val="tx1"/>
+          </a:fontRef>
+        </p:style>
+      </p:cxnSp>
+      <p:cxnSp>
+        <p:nvCxnSpPr>
+          <p:cNvPr id="88" name="Straight Arrow Connector 87"/>
+          <p:cNvCxnSpPr/>
+          <p:nvPr/>
+        </p:nvCxnSpPr>
+        <p:spPr>
+          <a:xfrm>
+            <a:off x="3444600" y="1295400"/>
+            <a:ext cx="720000" cy="0"/>
+          </a:xfrm>
+          <a:prstGeom prst="straightConnector1">
+            <a:avLst/>
+          </a:prstGeom>
+          <a:ln>
+            <a:headEnd type="arrow" w="sm" len="sm"/>
+            <a:tailEnd type="arrow" w="sm" len="sm"/>
+          </a:ln>
+        </p:spPr>
+        <p:style>
+          <a:lnRef idx="1">
+            <a:schemeClr val="accent1"/>
+          </a:lnRef>
+          <a:fillRef idx="0">
+            <a:schemeClr val="accent1"/>
+          </a:fillRef>
+          <a:effectRef idx="0">
+            <a:schemeClr val="accent1"/>
+          </a:effectRef>
+          <a:fontRef idx="minor">
+            <a:schemeClr val="tx1"/>
+          </a:fontRef>
+        </p:style>
+      </p:cxnSp>
+      <p:cxnSp>
+        <p:nvCxnSpPr>
+          <p:cNvPr id="91" name="Straight Arrow Connector 90"/>
+          <p:cNvCxnSpPr/>
+          <p:nvPr/>
+        </p:nvCxnSpPr>
+        <p:spPr>
+          <a:xfrm>
+            <a:off x="4164600" y="1295400"/>
+            <a:ext cx="720000" cy="0"/>
+          </a:xfrm>
+          <a:prstGeom prst="straightConnector1">
+            <a:avLst/>
+          </a:prstGeom>
+          <a:ln>
+            <a:headEnd type="arrow" w="sm" len="sm"/>
+            <a:tailEnd type="arrow" w="sm" len="sm"/>
+          </a:ln>
+        </p:spPr>
+        <p:style>
+          <a:lnRef idx="1">
+            <a:schemeClr val="accent1"/>
+          </a:lnRef>
+          <a:fillRef idx="0">
+            <a:schemeClr val="accent1"/>
+          </a:fillRef>
+          <a:effectRef idx="0">
+            <a:schemeClr val="accent1"/>
+          </a:effectRef>
+          <a:fontRef idx="minor">
+            <a:schemeClr val="tx1"/>
+          </a:fontRef>
+        </p:style>
+      </p:cxnSp>
+      <p:cxnSp>
+        <p:nvCxnSpPr>
+          <p:cNvPr id="92" name="Straight Arrow Connector 91"/>
+          <p:cNvCxnSpPr/>
+          <p:nvPr/>
+        </p:nvCxnSpPr>
+        <p:spPr>
+          <a:xfrm>
+            <a:off x="4884600" y="1295400"/>
+            <a:ext cx="720000" cy="0"/>
+          </a:xfrm>
+          <a:prstGeom prst="straightConnector1">
+            <a:avLst/>
+          </a:prstGeom>
+          <a:ln>
+            <a:headEnd type="arrow" w="sm" len="sm"/>
+            <a:tailEnd type="arrow" w="sm" len="sm"/>
+          </a:ln>
+        </p:spPr>
+        <p:style>
+          <a:lnRef idx="1">
+            <a:schemeClr val="accent1"/>
+          </a:lnRef>
+          <a:fillRef idx="0">
+            <a:schemeClr val="accent1"/>
+          </a:fillRef>
+          <a:effectRef idx="0">
+            <a:schemeClr val="accent1"/>
+          </a:effectRef>
+          <a:fontRef idx="minor">
+            <a:schemeClr val="tx1"/>
+          </a:fontRef>
+        </p:style>
+      </p:cxnSp>
+      <p:sp>
+        <p:nvSpPr>
+          <p:cNvPr id="93" name="TextBox 92"/>
+          <p:cNvSpPr txBox="1"/>
+          <p:nvPr/>
+        </p:nvSpPr>
+        <p:spPr>
+          <a:xfrm>
+            <a:off x="2111614" y="3545907"/>
+            <a:ext cx="649537" cy="338554"/>
+          </a:xfrm>
+          <a:prstGeom prst="rect">
+            <a:avLst/>
+          </a:prstGeom>
+          <a:noFill/>
+        </p:spPr>
+        <p:txBody>
+          <a:bodyPr wrap="none" rtlCol="0">
+            <a:spAutoFit/>
+          </a:bodyPr>
+          <a:lstStyle/>
+          <a:p>
+            <a:r>
+              <a:rPr lang="en-GB" sz="1600" dirty="0" smtClean="0"/>
+              <a:t>DBUS</a:t>
+            </a:r>
+            <a:endParaRPr lang="en-GB" sz="1600" dirty="0"/>
+          </a:p>
+        </p:txBody>
+      </p:sp>
+      <p:cxnSp>
+        <p:nvCxnSpPr>
+          <p:cNvPr id="94" name="Straight Connector 93"/>
+          <p:cNvCxnSpPr/>
+          <p:nvPr/>
+        </p:nvCxnSpPr>
+        <p:spPr>
+          <a:xfrm>
+            <a:off x="2724600" y="3711600"/>
+            <a:ext cx="842400" cy="0"/>
+          </a:xfrm>
+          <a:prstGeom prst="line">
+            <a:avLst/>
+          </a:prstGeom>
+          <a:ln>
+            <a:prstDash val="sysDash"/>
+          </a:ln>
+        </p:spPr>
+        <p:style>
+          <a:lnRef idx="1">
+            <a:schemeClr val="accent1"/>
+          </a:lnRef>
+          <a:fillRef idx="0">
+            <a:schemeClr val="accent1"/>
+          </a:fillRef>
+          <a:effectRef idx="0">
+            <a:schemeClr val="accent1"/>
+          </a:effectRef>
+          <a:fontRef idx="minor">
+            <a:schemeClr val="tx1"/>
+          </a:fontRef>
+        </p:style>
+      </p:cxnSp>
+      <p:cxnSp>
+        <p:nvCxnSpPr>
+          <p:cNvPr id="95" name="Straight Connector 94"/>
+          <p:cNvCxnSpPr/>
+          <p:nvPr/>
+        </p:nvCxnSpPr>
+        <p:spPr>
+          <a:xfrm>
+            <a:off x="3567000" y="3533040"/>
+            <a:ext cx="0" cy="360000"/>
+          </a:xfrm>
+          <a:prstGeom prst="line">
+            <a:avLst/>
+          </a:prstGeom>
+        </p:spPr>
+        <p:style>
+          <a:lnRef idx="1">
+            <a:schemeClr val="accent1"/>
+          </a:lnRef>
+          <a:fillRef idx="0">
+            <a:schemeClr val="accent1"/>
+          </a:fillRef>
+          <a:effectRef idx="0">
+            <a:schemeClr val="accent1"/>
+          </a:effectRef>
+          <a:fontRef idx="minor">
+            <a:schemeClr val="tx1"/>
+          </a:fontRef>
+        </p:style>
+      </p:cxnSp>
+      <p:cxnSp>
+        <p:nvCxnSpPr>
+          <p:cNvPr id="96" name="Straight Connector 95"/>
+          <p:cNvCxnSpPr/>
+          <p:nvPr/>
+        </p:nvCxnSpPr>
+        <p:spPr>
+          <a:xfrm>
+            <a:off x="3567000" y="3893040"/>
+            <a:ext cx="1440000" cy="0"/>
+          </a:xfrm>
+          <a:prstGeom prst="line">
+            <a:avLst/>
+          </a:prstGeom>
+        </p:spPr>
+        <p:style>
+          <a:lnRef idx="1">
+            <a:schemeClr val="accent1"/>
+          </a:lnRef>
+          <a:fillRef idx="0">
+            <a:schemeClr val="accent1"/>
+          </a:fillRef>
+          <a:effectRef idx="0">
+            <a:schemeClr val="accent1"/>
+          </a:effectRef>
+          <a:fontRef idx="minor">
+            <a:schemeClr val="tx1"/>
+          </a:fontRef>
+        </p:style>
+      </p:cxnSp>
+      <p:cxnSp>
+        <p:nvCxnSpPr>
+          <p:cNvPr id="97" name="Straight Connector 96"/>
+          <p:cNvCxnSpPr/>
+          <p:nvPr/>
+        </p:nvCxnSpPr>
+        <p:spPr>
+          <a:xfrm>
+            <a:off x="3567000" y="3533040"/>
+            <a:ext cx="1440000" cy="0"/>
+          </a:xfrm>
+          <a:prstGeom prst="line">
+            <a:avLst/>
+          </a:prstGeom>
+        </p:spPr>
+        <p:style>
+          <a:lnRef idx="1">
+            <a:schemeClr val="accent1"/>
+          </a:lnRef>
+          <a:fillRef idx="0">
+            <a:schemeClr val="accent1"/>
+          </a:fillRef>
+          <a:effectRef idx="0">
+            <a:schemeClr val="accent1"/>
+          </a:effectRef>
+          <a:fontRef idx="minor">
+            <a:schemeClr val="tx1"/>
+          </a:fontRef>
+        </p:style>
+      </p:cxnSp>
+      <p:cxnSp>
+        <p:nvCxnSpPr>
+          <p:cNvPr id="98" name="Straight Connector 97"/>
+          <p:cNvCxnSpPr/>
+          <p:nvPr/>
+        </p:nvCxnSpPr>
+        <p:spPr>
+          <a:xfrm>
+            <a:off x="5007000" y="3533040"/>
+            <a:ext cx="0" cy="360000"/>
+          </a:xfrm>
+          <a:prstGeom prst="line">
+            <a:avLst/>
+          </a:prstGeom>
+        </p:spPr>
+        <p:style>
+          <a:lnRef idx="1">
+            <a:schemeClr val="accent1"/>
+          </a:lnRef>
+          <a:fillRef idx="0">
+            <a:schemeClr val="accent1"/>
+          </a:fillRef>
+          <a:effectRef idx="0">
+            <a:schemeClr val="accent1"/>
+          </a:effectRef>
+          <a:fontRef idx="minor">
+            <a:schemeClr val="tx1"/>
+          </a:fontRef>
+        </p:style>
+      </p:cxnSp>
+      <p:cxnSp>
+        <p:nvCxnSpPr>
+          <p:cNvPr id="99" name="Straight Connector 98"/>
+          <p:cNvCxnSpPr/>
+          <p:nvPr/>
+        </p:nvCxnSpPr>
+        <p:spPr>
+          <a:xfrm>
+            <a:off x="5007000" y="3711600"/>
+            <a:ext cx="597600" cy="0"/>
+          </a:xfrm>
+          <a:prstGeom prst="line">
+            <a:avLst/>
+          </a:prstGeom>
+          <a:ln>
+            <a:prstDash val="sysDash"/>
+          </a:ln>
+        </p:spPr>
+        <p:style>
+          <a:lnRef idx="1">
+            <a:schemeClr val="accent1"/>
+          </a:lnRef>
+          <a:fillRef idx="0">
+            <a:schemeClr val="accent1"/>
+          </a:fillRef>
+          <a:effectRef idx="0">
+            <a:schemeClr val="accent1"/>
+          </a:effectRef>
+          <a:fontRef idx="minor">
+            <a:schemeClr val="tx1"/>
+          </a:fontRef>
+        </p:style>
+      </p:cxnSp>
+      <p:sp>
+        <p:nvSpPr>
+          <p:cNvPr id="100" name="TextBox 99"/>
+          <p:cNvSpPr txBox="1"/>
+          <p:nvPr/>
+        </p:nvSpPr>
+        <p:spPr>
+          <a:xfrm>
+            <a:off x="2888352" y="990600"/>
+            <a:ext cx="388248" cy="338554"/>
+          </a:xfrm>
+          <a:prstGeom prst="rect">
+            <a:avLst/>
+          </a:prstGeom>
+          <a:noFill/>
+        </p:spPr>
+        <p:txBody>
+          <a:bodyPr wrap="none" rtlCol="0">
+            <a:spAutoFit/>
+          </a:bodyPr>
+          <a:lstStyle/>
+          <a:p>
+            <a:r>
+              <a:rPr lang="en-GB" sz="1600" dirty="0" smtClean="0"/>
+              <a:t>T0</a:t>
+            </a:r>
+            <a:endParaRPr lang="en-GB" sz="1600" dirty="0"/>
+          </a:p>
+        </p:txBody>
+      </p:sp>
+      <p:sp>
+        <p:nvSpPr>
+          <p:cNvPr id="101" name="TextBox 100"/>
+          <p:cNvSpPr txBox="1"/>
+          <p:nvPr/>
+        </p:nvSpPr>
+        <p:spPr>
+          <a:xfrm>
+            <a:off x="3605568" y="990600"/>
+            <a:ext cx="388248" cy="338554"/>
+          </a:xfrm>
+          <a:prstGeom prst="rect">
+            <a:avLst/>
+          </a:prstGeom>
+          <a:noFill/>
+        </p:spPr>
+        <p:txBody>
+          <a:bodyPr wrap="none" rtlCol="0">
+            <a:spAutoFit/>
+          </a:bodyPr>
+          <a:lstStyle/>
+          <a:p>
+            <a:r>
+              <a:rPr lang="en-GB" sz="1600" dirty="0" smtClean="0"/>
+              <a:t>T1</a:t>
+            </a:r>
+            <a:endParaRPr lang="en-GB" sz="1600" dirty="0"/>
+          </a:p>
+        </p:txBody>
+      </p:sp>
+      <p:sp>
+        <p:nvSpPr>
+          <p:cNvPr id="102" name="TextBox 101"/>
+          <p:cNvSpPr txBox="1"/>
+          <p:nvPr/>
+        </p:nvSpPr>
+        <p:spPr>
+          <a:xfrm>
+            <a:off x="4322784" y="990600"/>
+            <a:ext cx="388248" cy="338554"/>
+          </a:xfrm>
+          <a:prstGeom prst="rect">
+            <a:avLst/>
+          </a:prstGeom>
+          <a:noFill/>
+        </p:spPr>
+        <p:txBody>
+          <a:bodyPr wrap="none" rtlCol="0">
+            <a:spAutoFit/>
+          </a:bodyPr>
+          <a:lstStyle/>
+          <a:p>
+            <a:r>
+              <a:rPr lang="en-GB" sz="1600" dirty="0" smtClean="0"/>
+              <a:t>T2</a:t>
+            </a:r>
+            <a:endParaRPr lang="en-GB" sz="1600" dirty="0"/>
+          </a:p>
+        </p:txBody>
+      </p:sp>
+      <p:sp>
+        <p:nvSpPr>
+          <p:cNvPr id="103" name="TextBox 102"/>
+          <p:cNvSpPr txBox="1"/>
+          <p:nvPr/>
+        </p:nvSpPr>
+        <p:spPr>
+          <a:xfrm>
+            <a:off x="5040000" y="990600"/>
+            <a:ext cx="388248" cy="338554"/>
+          </a:xfrm>
+          <a:prstGeom prst="rect">
+            <a:avLst/>
+          </a:prstGeom>
+          <a:noFill/>
+        </p:spPr>
+        <p:txBody>
+          <a:bodyPr wrap="none" rtlCol="0">
+            <a:spAutoFit/>
+          </a:bodyPr>
+          <a:lstStyle/>
+          <a:p>
+            <a:r>
+              <a:rPr lang="en-GB" sz="1600" dirty="0" smtClean="0"/>
+              <a:t>T3</a:t>
+            </a:r>
+            <a:endParaRPr lang="en-GB" sz="1600" dirty="0"/>
+          </a:p>
+        </p:txBody>
+      </p:sp>
+      <p:sp>
+        <p:nvSpPr>
+          <p:cNvPr id="104" name="TextBox 103"/>
+          <p:cNvSpPr txBox="1"/>
+          <p:nvPr/>
+        </p:nvSpPr>
+        <p:spPr>
+          <a:xfrm>
+            <a:off x="2827553" y="3581400"/>
+            <a:ext cx="601447" cy="246221"/>
+          </a:xfrm>
+          <a:prstGeom prst="rect">
+            <a:avLst/>
+          </a:prstGeom>
+          <a:noFill/>
+        </p:spPr>
+        <p:txBody>
+          <a:bodyPr wrap="none" rtlCol="0">
+            <a:spAutoFit/>
+          </a:bodyPr>
+          <a:lstStyle/>
+          <a:p>
+            <a:r>
+              <a:rPr lang="en-GB" sz="1000" dirty="0" smtClean="0"/>
+              <a:t>Floating</a:t>
+            </a:r>
+            <a:endParaRPr lang="en-GB" sz="1000" dirty="0"/>
+          </a:p>
+        </p:txBody>
+      </p:sp>
+      <p:sp>
+        <p:nvSpPr>
+          <p:cNvPr id="105" name="TextBox 104"/>
+          <p:cNvSpPr txBox="1"/>
+          <p:nvPr/>
+        </p:nvSpPr>
+        <p:spPr>
+          <a:xfrm>
+            <a:off x="5037353" y="3581400"/>
+            <a:ext cx="601447" cy="246221"/>
+          </a:xfrm>
+          <a:prstGeom prst="rect">
+            <a:avLst/>
+          </a:prstGeom>
+          <a:noFill/>
+        </p:spPr>
+        <p:txBody>
+          <a:bodyPr wrap="none" rtlCol="0">
+            <a:spAutoFit/>
+          </a:bodyPr>
+          <a:lstStyle/>
+          <a:p>
+            <a:r>
+              <a:rPr lang="en-GB" sz="1000" dirty="0" smtClean="0"/>
+              <a:t>Floating</a:t>
+            </a:r>
+            <a:endParaRPr lang="en-GB" sz="1000" dirty="0"/>
+          </a:p>
+        </p:txBody>
+      </p:sp>
+      <p:sp>
+        <p:nvSpPr>
+          <p:cNvPr id="106" name="TextBox 105"/>
+          <p:cNvSpPr txBox="1"/>
+          <p:nvPr/>
+        </p:nvSpPr>
+        <p:spPr>
+          <a:xfrm>
+            <a:off x="3970553" y="3581400"/>
+            <a:ext cx="700833" cy="246221"/>
+          </a:xfrm>
+          <a:prstGeom prst="rect">
+            <a:avLst/>
+          </a:prstGeom>
+          <a:noFill/>
+        </p:spPr>
+        <p:txBody>
+          <a:bodyPr wrap="none" rtlCol="0">
+            <a:spAutoFit/>
+          </a:bodyPr>
+          <a:lstStyle/>
+          <a:p>
+            <a:r>
+              <a:rPr lang="en-GB" sz="1000" dirty="0" smtClean="0"/>
+              <a:t>Data valid</a:t>
+            </a:r>
+            <a:endParaRPr lang="en-GB" sz="1000" dirty="0"/>
           </a:p>
         </p:txBody>
       </p:sp>

</xml_diff>

<commit_message>
Remove READ and WRITE
</commit_message>
<xml_diff>
--- a/CPU Design/L1IsDrawings.pptx
+++ b/CPU Design/L1IsDrawings.pptx
@@ -291,7 +291,7 @@
             <a:fld id="{1D8BD707-D9CF-40AE-B4C6-C98DA3205C09}" type="datetimeFigureOut">
               <a:rPr lang="en-US" smtClean="0"/>
               <a:pPr/>
-              <a:t>6/29/2026</a:t>
+              <a:t>6/30/2026</a:t>
             </a:fld>
             <a:endParaRPr lang="en-US"/>
           </a:p>
@@ -458,7 +458,7 @@
             <a:fld id="{1D8BD707-D9CF-40AE-B4C6-C98DA3205C09}" type="datetimeFigureOut">
               <a:rPr lang="en-US" smtClean="0"/>
               <a:pPr/>
-              <a:t>6/29/2026</a:t>
+              <a:t>6/30/2026</a:t>
             </a:fld>
             <a:endParaRPr lang="en-US"/>
           </a:p>
@@ -635,7 +635,7 @@
             <a:fld id="{1D8BD707-D9CF-40AE-B4C6-C98DA3205C09}" type="datetimeFigureOut">
               <a:rPr lang="en-US" smtClean="0"/>
               <a:pPr/>
-              <a:t>6/29/2026</a:t>
+              <a:t>6/30/2026</a:t>
             </a:fld>
             <a:endParaRPr lang="en-US"/>
           </a:p>
@@ -802,7 +802,7 @@
             <a:fld id="{1D8BD707-D9CF-40AE-B4C6-C98DA3205C09}" type="datetimeFigureOut">
               <a:rPr lang="en-US" smtClean="0"/>
               <a:pPr/>
-              <a:t>6/29/2026</a:t>
+              <a:t>6/30/2026</a:t>
             </a:fld>
             <a:endParaRPr lang="en-US"/>
           </a:p>
@@ -1045,7 +1045,7 @@
             <a:fld id="{1D8BD707-D9CF-40AE-B4C6-C98DA3205C09}" type="datetimeFigureOut">
               <a:rPr lang="en-US" smtClean="0"/>
               <a:pPr/>
-              <a:t>6/29/2026</a:t>
+              <a:t>6/30/2026</a:t>
             </a:fld>
             <a:endParaRPr lang="en-US"/>
           </a:p>
@@ -1330,7 +1330,7 @@
             <a:fld id="{1D8BD707-D9CF-40AE-B4C6-C98DA3205C09}" type="datetimeFigureOut">
               <a:rPr lang="en-US" smtClean="0"/>
               <a:pPr/>
-              <a:t>6/29/2026</a:t>
+              <a:t>6/30/2026</a:t>
             </a:fld>
             <a:endParaRPr lang="en-US"/>
           </a:p>
@@ -1749,7 +1749,7 @@
             <a:fld id="{1D8BD707-D9CF-40AE-B4C6-C98DA3205C09}" type="datetimeFigureOut">
               <a:rPr lang="en-US" smtClean="0"/>
               <a:pPr/>
-              <a:t>6/29/2026</a:t>
+              <a:t>6/30/2026</a:t>
             </a:fld>
             <a:endParaRPr lang="en-US"/>
           </a:p>
@@ -1864,7 +1864,7 @@
             <a:fld id="{1D8BD707-D9CF-40AE-B4C6-C98DA3205C09}" type="datetimeFigureOut">
               <a:rPr lang="en-US" smtClean="0"/>
               <a:pPr/>
-              <a:t>6/29/2026</a:t>
+              <a:t>6/30/2026</a:t>
             </a:fld>
             <a:endParaRPr lang="en-US"/>
           </a:p>
@@ -1956,7 +1956,7 @@
             <a:fld id="{1D8BD707-D9CF-40AE-B4C6-C98DA3205C09}" type="datetimeFigureOut">
               <a:rPr lang="en-US" smtClean="0"/>
               <a:pPr/>
-              <a:t>6/29/2026</a:t>
+              <a:t>6/30/2026</a:t>
             </a:fld>
             <a:endParaRPr lang="en-US"/>
           </a:p>
@@ -2230,7 +2230,7 @@
             <a:fld id="{1D8BD707-D9CF-40AE-B4C6-C98DA3205C09}" type="datetimeFigureOut">
               <a:rPr lang="en-US" smtClean="0"/>
               <a:pPr/>
-              <a:t>6/29/2026</a:t>
+              <a:t>6/30/2026</a:t>
             </a:fld>
             <a:endParaRPr lang="en-US"/>
           </a:p>
@@ -2480,7 +2480,7 @@
             <a:fld id="{1D8BD707-D9CF-40AE-B4C6-C98DA3205C09}" type="datetimeFigureOut">
               <a:rPr lang="en-US" smtClean="0"/>
               <a:pPr/>
-              <a:t>6/29/2026</a:t>
+              <a:t>6/30/2026</a:t>
             </a:fld>
             <a:endParaRPr lang="en-US"/>
           </a:p>
@@ -2690,7 +2690,7 @@
             <a:fld id="{1D8BD707-D9CF-40AE-B4C6-C98DA3205C09}" type="datetimeFigureOut">
               <a:rPr lang="en-US" smtClean="0"/>
               <a:pPr/>
-              <a:t>6/29/2026</a:t>
+              <a:t>6/30/2026</a:t>
             </a:fld>
             <a:endParaRPr lang="en-US"/>
           </a:p>
@@ -3613,7 +3613,7 @@
         <p:spPr>
           <a:xfrm>
             <a:off x="2724600" y="1295400"/>
-            <a:ext cx="0" cy="4104000"/>
+            <a:ext cx="0" cy="2592000"/>
           </a:xfrm>
           <a:prstGeom prst="line">
             <a:avLst/>
@@ -3651,7 +3651,7 @@
         <p:spPr>
           <a:xfrm>
             <a:off x="3444600" y="1295400"/>
-            <a:ext cx="0" cy="4104000"/>
+            <a:ext cx="0" cy="2592000"/>
           </a:xfrm>
           <a:prstGeom prst="line">
             <a:avLst/>
@@ -3689,7 +3689,7 @@
         <p:spPr>
           <a:xfrm>
             <a:off x="4164600" y="1295400"/>
-            <a:ext cx="0" cy="4104000"/>
+            <a:ext cx="0" cy="2592000"/>
           </a:xfrm>
           <a:prstGeom prst="line">
             <a:avLst/>
@@ -3727,7 +3727,7 @@
         <p:spPr>
           <a:xfrm>
             <a:off x="4884600" y="1295400"/>
-            <a:ext cx="0" cy="4104000"/>
+            <a:ext cx="0" cy="2592000"/>
           </a:xfrm>
           <a:prstGeom prst="line">
             <a:avLst/>
@@ -3765,7 +3765,7 @@
         <p:spPr>
           <a:xfrm>
             <a:off x="5604600" y="1295400"/>
-            <a:ext cx="0" cy="4104000"/>
+            <a:ext cx="0" cy="2592000"/>
           </a:xfrm>
           <a:prstGeom prst="line">
             <a:avLst/>
@@ -4336,14 +4336,14 @@
       </p:sp>
       <p:sp>
         <p:nvSpPr>
-          <p:cNvPr id="53" name="TextBox 52"/>
+          <p:cNvPr id="54" name="TextBox 53"/>
           <p:cNvSpPr txBox="1"/>
           <p:nvPr/>
         </p:nvSpPr>
         <p:spPr>
           <a:xfrm>
-            <a:off x="2029861" y="2248769"/>
-            <a:ext cx="731290" cy="338554"/>
+            <a:off x="1052029" y="2163178"/>
+            <a:ext cx="1709122" cy="338554"/>
           </a:xfrm>
           <a:prstGeom prst="rect">
             <a:avLst/>
@@ -4358,7 +4358,7 @@
           <a:p>
             <a:r>
               <a:rPr lang="en-GB" sz="1600" dirty="0" smtClean="0"/>
-              <a:t>WRITE</a:t>
+              <a:t>SELECT &lt;SOURCE&gt;</a:t>
             </a:r>
             <a:endParaRPr lang="en-GB" sz="1600" dirty="0"/>
           </a:p>
@@ -4366,14 +4366,14 @@
       </p:sp>
       <p:sp>
         <p:nvSpPr>
-          <p:cNvPr id="54" name="TextBox 53"/>
+          <p:cNvPr id="56" name="TextBox 55"/>
           <p:cNvSpPr txBox="1"/>
           <p:nvPr/>
         </p:nvSpPr>
         <p:spPr>
           <a:xfrm>
-            <a:off x="1052029" y="2897338"/>
-            <a:ext cx="1709122" cy="338554"/>
+            <a:off x="609600" y="3298046"/>
+            <a:ext cx="2151551" cy="338554"/>
           </a:xfrm>
           <a:prstGeom prst="rect">
             <a:avLst/>
@@ -4388,222 +4388,12 @@
           <a:p>
             <a:r>
               <a:rPr lang="en-GB" sz="1600" dirty="0" smtClean="0"/>
-              <a:t>SELECT &lt;SOURCE&gt;</a:t>
+              <a:t>SELECT &lt;DESTINATION&gt;</a:t>
             </a:r>
             <a:endParaRPr lang="en-GB" sz="1600" dirty="0"/>
           </a:p>
         </p:txBody>
       </p:sp>
-      <p:sp>
-        <p:nvSpPr>
-          <p:cNvPr id="55" name="TextBox 54"/>
-          <p:cNvSpPr txBox="1"/>
-          <p:nvPr/>
-        </p:nvSpPr>
-        <p:spPr>
-          <a:xfrm>
-            <a:off x="2120206" y="4194476"/>
-            <a:ext cx="640945" cy="338554"/>
-          </a:xfrm>
-          <a:prstGeom prst="rect">
-            <a:avLst/>
-          </a:prstGeom>
-          <a:noFill/>
-        </p:spPr>
-        <p:txBody>
-          <a:bodyPr wrap="none" rtlCol="0">
-            <a:spAutoFit/>
-          </a:bodyPr>
-          <a:lstStyle/>
-          <a:p>
-            <a:r>
-              <a:rPr lang="en-GB" sz="1600" dirty="0" smtClean="0"/>
-              <a:t>READ</a:t>
-            </a:r>
-            <a:endParaRPr lang="en-GB" sz="1600" dirty="0"/>
-          </a:p>
-        </p:txBody>
-      </p:sp>
-      <p:sp>
-        <p:nvSpPr>
-          <p:cNvPr id="56" name="TextBox 55"/>
-          <p:cNvSpPr txBox="1"/>
-          <p:nvPr/>
-        </p:nvSpPr>
-        <p:spPr>
-          <a:xfrm>
-            <a:off x="609600" y="4843046"/>
-            <a:ext cx="2151551" cy="338554"/>
-          </a:xfrm>
-          <a:prstGeom prst="rect">
-            <a:avLst/>
-          </a:prstGeom>
-          <a:noFill/>
-        </p:spPr>
-        <p:txBody>
-          <a:bodyPr wrap="none" rtlCol="0">
-            <a:spAutoFit/>
-          </a:bodyPr>
-          <a:lstStyle/>
-          <a:p>
-            <a:r>
-              <a:rPr lang="en-GB" sz="1600" dirty="0" smtClean="0"/>
-              <a:t>SELECT &lt;DESTINATION&gt;</a:t>
-            </a:r>
-            <a:endParaRPr lang="en-GB" sz="1600" dirty="0"/>
-          </a:p>
-        </p:txBody>
-      </p:sp>
-      <p:cxnSp>
-        <p:nvCxnSpPr>
-          <p:cNvPr id="57" name="Straight Connector 56"/>
-          <p:cNvCxnSpPr/>
-          <p:nvPr/>
-        </p:nvCxnSpPr>
-        <p:spPr>
-          <a:xfrm>
-            <a:off x="2724600" y="2604480"/>
-            <a:ext cx="781200" cy="0"/>
-          </a:xfrm>
-          <a:prstGeom prst="line">
-            <a:avLst/>
-          </a:prstGeom>
-        </p:spPr>
-        <p:style>
-          <a:lnRef idx="1">
-            <a:schemeClr val="accent1"/>
-          </a:lnRef>
-          <a:fillRef idx="0">
-            <a:schemeClr val="accent1"/>
-          </a:fillRef>
-          <a:effectRef idx="0">
-            <a:schemeClr val="accent1"/>
-          </a:effectRef>
-          <a:fontRef idx="minor">
-            <a:schemeClr val="tx1"/>
-          </a:fontRef>
-        </p:style>
-      </p:cxnSp>
-      <p:cxnSp>
-        <p:nvCxnSpPr>
-          <p:cNvPr id="58" name="Straight Connector 57"/>
-          <p:cNvCxnSpPr/>
-          <p:nvPr/>
-        </p:nvCxnSpPr>
-        <p:spPr>
-          <a:xfrm>
-            <a:off x="3505200" y="2244480"/>
-            <a:ext cx="0" cy="360000"/>
-          </a:xfrm>
-          <a:prstGeom prst="line">
-            <a:avLst/>
-          </a:prstGeom>
-        </p:spPr>
-        <p:style>
-          <a:lnRef idx="1">
-            <a:schemeClr val="accent1"/>
-          </a:lnRef>
-          <a:fillRef idx="0">
-            <a:schemeClr val="accent1"/>
-          </a:fillRef>
-          <a:effectRef idx="0">
-            <a:schemeClr val="accent1"/>
-          </a:effectRef>
-          <a:fontRef idx="minor">
-            <a:schemeClr val="tx1"/>
-          </a:fontRef>
-        </p:style>
-      </p:cxnSp>
-      <p:cxnSp>
-        <p:nvCxnSpPr>
-          <p:cNvPr id="59" name="Straight Connector 58"/>
-          <p:cNvCxnSpPr/>
-          <p:nvPr/>
-        </p:nvCxnSpPr>
-        <p:spPr>
-          <a:xfrm>
-            <a:off x="4946400" y="2244480"/>
-            <a:ext cx="0" cy="360000"/>
-          </a:xfrm>
-          <a:prstGeom prst="line">
-            <a:avLst/>
-          </a:prstGeom>
-        </p:spPr>
-        <p:style>
-          <a:lnRef idx="1">
-            <a:schemeClr val="accent1"/>
-          </a:lnRef>
-          <a:fillRef idx="0">
-            <a:schemeClr val="accent1"/>
-          </a:fillRef>
-          <a:effectRef idx="0">
-            <a:schemeClr val="accent1"/>
-          </a:effectRef>
-          <a:fontRef idx="minor">
-            <a:schemeClr val="tx1"/>
-          </a:fontRef>
-        </p:style>
-      </p:cxnSp>
-      <p:cxnSp>
-        <p:nvCxnSpPr>
-          <p:cNvPr id="60" name="Straight Connector 59"/>
-          <p:cNvCxnSpPr/>
-          <p:nvPr/>
-        </p:nvCxnSpPr>
-        <p:spPr>
-          <a:xfrm>
-            <a:off x="3505200" y="2244480"/>
-            <a:ext cx="1440000" cy="0"/>
-          </a:xfrm>
-          <a:prstGeom prst="line">
-            <a:avLst/>
-          </a:prstGeom>
-        </p:spPr>
-        <p:style>
-          <a:lnRef idx="1">
-            <a:schemeClr val="accent1"/>
-          </a:lnRef>
-          <a:fillRef idx="0">
-            <a:schemeClr val="accent1"/>
-          </a:fillRef>
-          <a:effectRef idx="0">
-            <a:schemeClr val="accent1"/>
-          </a:effectRef>
-          <a:fontRef idx="minor">
-            <a:schemeClr val="tx1"/>
-          </a:fontRef>
-        </p:style>
-      </p:cxnSp>
-      <p:cxnSp>
-        <p:nvCxnSpPr>
-          <p:cNvPr id="62" name="Straight Connector 61"/>
-          <p:cNvCxnSpPr/>
-          <p:nvPr/>
-        </p:nvCxnSpPr>
-        <p:spPr>
-          <a:xfrm>
-            <a:off x="4946400" y="2604480"/>
-            <a:ext cx="658800" cy="0"/>
-          </a:xfrm>
-          <a:prstGeom prst="line">
-            <a:avLst/>
-          </a:prstGeom>
-        </p:spPr>
-        <p:style>
-          <a:lnRef idx="1">
-            <a:schemeClr val="accent1"/>
-          </a:lnRef>
-          <a:fillRef idx="0">
-            <a:schemeClr val="accent1"/>
-          </a:fillRef>
-          <a:effectRef idx="0">
-            <a:schemeClr val="accent1"/>
-          </a:effectRef>
-          <a:fontRef idx="minor">
-            <a:schemeClr val="tx1"/>
-          </a:fontRef>
-        </p:style>
-      </p:cxnSp>
       <p:cxnSp>
         <p:nvCxnSpPr>
           <p:cNvPr id="63" name="Straight Connector 62"/>
@@ -4612,7 +4402,7 @@
         </p:nvCxnSpPr>
         <p:spPr>
           <a:xfrm>
-            <a:off x="2724600" y="3248760"/>
+            <a:off x="2724600" y="2514600"/>
             <a:ext cx="781200" cy="0"/>
           </a:xfrm>
           <a:prstGeom prst="line">
@@ -4642,7 +4432,7 @@
         </p:nvCxnSpPr>
         <p:spPr>
           <a:xfrm>
-            <a:off x="3505200" y="2888760"/>
+            <a:off x="3505200" y="2154600"/>
             <a:ext cx="0" cy="360000"/>
           </a:xfrm>
           <a:prstGeom prst="line">
@@ -4672,7 +4462,7 @@
         </p:nvCxnSpPr>
         <p:spPr>
           <a:xfrm>
-            <a:off x="4946400" y="2888760"/>
+            <a:off x="4946400" y="2154600"/>
             <a:ext cx="0" cy="360000"/>
           </a:xfrm>
           <a:prstGeom prst="line">
@@ -4702,7 +4492,7 @@
         </p:nvCxnSpPr>
         <p:spPr>
           <a:xfrm>
-            <a:off x="3505200" y="2888760"/>
+            <a:off x="3505200" y="2159000"/>
             <a:ext cx="1440000" cy="0"/>
           </a:xfrm>
           <a:prstGeom prst="line">
@@ -4732,157 +4522,7 @@
         </p:nvCxnSpPr>
         <p:spPr>
           <a:xfrm>
-            <a:off x="4946400" y="3248760"/>
-            <a:ext cx="658800" cy="0"/>
-          </a:xfrm>
-          <a:prstGeom prst="line">
-            <a:avLst/>
-          </a:prstGeom>
-        </p:spPr>
-        <p:style>
-          <a:lnRef idx="1">
-            <a:schemeClr val="accent1"/>
-          </a:lnRef>
-          <a:fillRef idx="0">
-            <a:schemeClr val="accent1"/>
-          </a:fillRef>
-          <a:effectRef idx="0">
-            <a:schemeClr val="accent1"/>
-          </a:effectRef>
-          <a:fontRef idx="minor">
-            <a:schemeClr val="tx1"/>
-          </a:fontRef>
-        </p:style>
-      </p:cxnSp>
-      <p:cxnSp>
-        <p:nvCxnSpPr>
-          <p:cNvPr id="68" name="Straight Connector 67"/>
-          <p:cNvCxnSpPr/>
-          <p:nvPr/>
-        </p:nvCxnSpPr>
-        <p:spPr>
-          <a:xfrm>
-            <a:off x="2724600" y="4537320"/>
-            <a:ext cx="1501200" cy="0"/>
-          </a:xfrm>
-          <a:prstGeom prst="line">
-            <a:avLst/>
-          </a:prstGeom>
-        </p:spPr>
-        <p:style>
-          <a:lnRef idx="1">
-            <a:schemeClr val="accent1"/>
-          </a:lnRef>
-          <a:fillRef idx="0">
-            <a:schemeClr val="accent1"/>
-          </a:fillRef>
-          <a:effectRef idx="0">
-            <a:schemeClr val="accent1"/>
-          </a:effectRef>
-          <a:fontRef idx="minor">
-            <a:schemeClr val="tx1"/>
-          </a:fontRef>
-        </p:style>
-      </p:cxnSp>
-      <p:cxnSp>
-        <p:nvCxnSpPr>
-          <p:cNvPr id="69" name="Straight Connector 68"/>
-          <p:cNvCxnSpPr/>
-          <p:nvPr/>
-        </p:nvCxnSpPr>
-        <p:spPr>
-          <a:xfrm>
-            <a:off x="4225800" y="4177320"/>
-            <a:ext cx="0" cy="360000"/>
-          </a:xfrm>
-          <a:prstGeom prst="line">
-            <a:avLst/>
-          </a:prstGeom>
-        </p:spPr>
-        <p:style>
-          <a:lnRef idx="1">
-            <a:schemeClr val="accent1"/>
-          </a:lnRef>
-          <a:fillRef idx="0">
-            <a:schemeClr val="accent1"/>
-          </a:fillRef>
-          <a:effectRef idx="0">
-            <a:schemeClr val="accent1"/>
-          </a:effectRef>
-          <a:fontRef idx="minor">
-            <a:schemeClr val="tx1"/>
-          </a:fontRef>
-        </p:style>
-      </p:cxnSp>
-      <p:cxnSp>
-        <p:nvCxnSpPr>
-          <p:cNvPr id="70" name="Straight Connector 69"/>
-          <p:cNvCxnSpPr/>
-          <p:nvPr/>
-        </p:nvCxnSpPr>
-        <p:spPr>
-          <a:xfrm>
-            <a:off x="4225800" y="4177320"/>
-            <a:ext cx="720000" cy="0"/>
-          </a:xfrm>
-          <a:prstGeom prst="line">
-            <a:avLst/>
-          </a:prstGeom>
-        </p:spPr>
-        <p:style>
-          <a:lnRef idx="1">
-            <a:schemeClr val="accent1"/>
-          </a:lnRef>
-          <a:fillRef idx="0">
-            <a:schemeClr val="accent1"/>
-          </a:fillRef>
-          <a:effectRef idx="0">
-            <a:schemeClr val="accent1"/>
-          </a:effectRef>
-          <a:fontRef idx="minor">
-            <a:schemeClr val="tx1"/>
-          </a:fontRef>
-        </p:style>
-      </p:cxnSp>
-      <p:cxnSp>
-        <p:nvCxnSpPr>
-          <p:cNvPr id="71" name="Straight Connector 70"/>
-          <p:cNvCxnSpPr/>
-          <p:nvPr/>
-        </p:nvCxnSpPr>
-        <p:spPr>
-          <a:xfrm>
-            <a:off x="4946400" y="4177320"/>
-            <a:ext cx="0" cy="360000"/>
-          </a:xfrm>
-          <a:prstGeom prst="line">
-            <a:avLst/>
-          </a:prstGeom>
-        </p:spPr>
-        <p:style>
-          <a:lnRef idx="1">
-            <a:schemeClr val="accent1"/>
-          </a:lnRef>
-          <a:fillRef idx="0">
-            <a:schemeClr val="accent1"/>
-          </a:fillRef>
-          <a:effectRef idx="0">
-            <a:schemeClr val="accent1"/>
-          </a:effectRef>
-          <a:fontRef idx="minor">
-            <a:schemeClr val="tx1"/>
-          </a:fontRef>
-        </p:style>
-      </p:cxnSp>
-      <p:cxnSp>
-        <p:nvCxnSpPr>
-          <p:cNvPr id="72" name="Straight Connector 71"/>
-          <p:cNvCxnSpPr/>
-          <p:nvPr/>
-        </p:nvCxnSpPr>
-        <p:spPr>
-          <a:xfrm>
-            <a:off x="4946400" y="4537320"/>
+            <a:off x="4946400" y="2514600"/>
             <a:ext cx="658800" cy="0"/>
           </a:xfrm>
           <a:prstGeom prst="line">
@@ -4912,7 +4552,7 @@
         </p:nvCxnSpPr>
         <p:spPr>
           <a:xfrm>
-            <a:off x="2724000" y="5181600"/>
+            <a:off x="2724000" y="3636600"/>
             <a:ext cx="1501200" cy="0"/>
           </a:xfrm>
           <a:prstGeom prst="line">
@@ -4942,7 +4582,7 @@
         </p:nvCxnSpPr>
         <p:spPr>
           <a:xfrm>
-            <a:off x="4225200" y="4821600"/>
+            <a:off x="4225200" y="3276600"/>
             <a:ext cx="0" cy="360000"/>
           </a:xfrm>
           <a:prstGeom prst="line">
@@ -4972,7 +4612,7 @@
         </p:nvCxnSpPr>
         <p:spPr>
           <a:xfrm>
-            <a:off x="4225200" y="4821600"/>
+            <a:off x="4225200" y="3276600"/>
             <a:ext cx="720000" cy="0"/>
           </a:xfrm>
           <a:prstGeom prst="line">
@@ -5002,7 +4642,7 @@
         </p:nvCxnSpPr>
         <p:spPr>
           <a:xfrm>
-            <a:off x="4945800" y="4821600"/>
+            <a:off x="4945800" y="3276600"/>
             <a:ext cx="0" cy="360000"/>
           </a:xfrm>
           <a:prstGeom prst="line">
@@ -5032,7 +4672,7 @@
         </p:nvCxnSpPr>
         <p:spPr>
           <a:xfrm>
-            <a:off x="4945800" y="5181600"/>
+            <a:off x="4945800" y="3636600"/>
             <a:ext cx="658800" cy="0"/>
           </a:xfrm>
           <a:prstGeom prst="line">
@@ -5198,7 +4838,7 @@
         </p:nvSpPr>
         <p:spPr>
           <a:xfrm>
-            <a:off x="2111614" y="3545907"/>
+            <a:off x="2111614" y="2700867"/>
             <a:ext cx="649537" cy="338554"/>
           </a:xfrm>
           <a:prstGeom prst="rect">
@@ -5228,7 +4868,7 @@
         </p:nvCxnSpPr>
         <p:spPr>
           <a:xfrm>
-            <a:off x="2724600" y="3711600"/>
+            <a:off x="2724600" y="2898000"/>
             <a:ext cx="842400" cy="0"/>
           </a:xfrm>
           <a:prstGeom prst="line">
@@ -5261,7 +4901,7 @@
         </p:nvCxnSpPr>
         <p:spPr>
           <a:xfrm>
-            <a:off x="3567000" y="3533040"/>
+            <a:off x="3567000" y="2717800"/>
             <a:ext cx="0" cy="360000"/>
           </a:xfrm>
           <a:prstGeom prst="line">
@@ -5291,7 +4931,7 @@
         </p:nvCxnSpPr>
         <p:spPr>
           <a:xfrm>
-            <a:off x="3567000" y="3893040"/>
+            <a:off x="3567000" y="3077800"/>
             <a:ext cx="1440000" cy="0"/>
           </a:xfrm>
           <a:prstGeom prst="line">
@@ -5321,7 +4961,7 @@
         </p:nvCxnSpPr>
         <p:spPr>
           <a:xfrm>
-            <a:off x="3567000" y="3533040"/>
+            <a:off x="3567000" y="2717800"/>
             <a:ext cx="1440000" cy="0"/>
           </a:xfrm>
           <a:prstGeom prst="line">
@@ -5351,7 +4991,7 @@
         </p:nvCxnSpPr>
         <p:spPr>
           <a:xfrm>
-            <a:off x="5007000" y="3533040"/>
+            <a:off x="5007000" y="2717800"/>
             <a:ext cx="0" cy="360000"/>
           </a:xfrm>
           <a:prstGeom prst="line">
@@ -5381,7 +5021,7 @@
         </p:nvCxnSpPr>
         <p:spPr>
           <a:xfrm>
-            <a:off x="5007000" y="3711600"/>
+            <a:off x="5007000" y="2898000"/>
             <a:ext cx="597600" cy="0"/>
           </a:xfrm>
           <a:prstGeom prst="line">
@@ -5534,7 +5174,7 @@
         </p:nvSpPr>
         <p:spPr>
           <a:xfrm>
-            <a:off x="2827553" y="3581400"/>
+            <a:off x="2827553" y="2764800"/>
             <a:ext cx="601447" cy="246221"/>
           </a:xfrm>
           <a:prstGeom prst="rect">
@@ -5564,7 +5204,7 @@
         </p:nvSpPr>
         <p:spPr>
           <a:xfrm>
-            <a:off x="5037353" y="3581400"/>
+            <a:off x="5037353" y="2764800"/>
             <a:ext cx="601447" cy="246221"/>
           </a:xfrm>
           <a:prstGeom prst="rect">
@@ -5594,7 +5234,7 @@
         </p:nvSpPr>
         <p:spPr>
           <a:xfrm>
-            <a:off x="3970553" y="3581400"/>
+            <a:off x="3970553" y="2764800"/>
             <a:ext cx="700833" cy="246221"/>
           </a:xfrm>
           <a:prstGeom prst="rect">

</xml_diff>